<commit_message>
docs(deliverable): humanize deck, add AI narrative + architecture diagram
- Rewrite copy in a plain, human voice (drop "curated performance" and
  the "management program" framing).
- Reframe the process story around leveraging AI: rich context + exact
  scope, with the first weeks spent on ADRs/tickets/governance.
- Add a real labeled architecture diagram slide (boxes, not just arrows).
- Pull app screenshots onto content slides (feed, analytics, landing,
  profile), not just the fallback appendix.
- Update presentation-spec.md to match, structured for Gamma import.

Co-Authored-By: Claude Opus 4.8 <noreply@anthropic.com>
</commit_message>
<xml_diff>
--- a/docs/presentation/brink-deck.pptx
+++ b/docs/presentation/brink-deck.pptx
@@ -523,7 +523,7 @@
           <a:lstStyle/>
           <a:p>
             <a:r>
-              <a:t>ANDREA (0:20): We're Brink — a social network built on the music you actually listen to. I'm Andrea on the backend, Jonah built our analytics, and Sebastian built the frontend. It's live right now at this URL, and we'll demo it at the end.</a:t>
+              <a:t>ANDREA (0:20): Hi everyone — this is Brink. It's a social app built around the music you actually listen to on Spotify. I worked on the backend, Jonah did the analytics, and Sebastian did the frontend. It's deployed and running, so we'll show you the real thing at the end.</a:t>
             </a:r>
           </a:p>
         </p:txBody>
@@ -593,7 +593,7 @@
           <a:lstStyle/>
           <a:p>
             <a:r>
-              <a:t>JONAH (1:15): Our data is organized in a medallion architecture — a standard data-engineering pattern. Bronze is raw, immutable landings: every Spotify 'recently played' pull and the raw Kaggle rows. Silver is cleaned, conformed data the app actually uses — the tracks and the plays. Gold is model output — the clusters and the trained model. We did this on plain free Postgres, no Spark or lakehouse — right-sized for the scale, and it gives us clean lineage we can point to.</a:t>
+              <a:t>JONAH (1:15): The data side is organised in three layers — people call it a medallion. The first layer is raw: everything exactly as it arrives, the Spotify listening pulls and the raw dataset rows. The second is that data cleaned up into the tables the app actually uses. And the third is the output of our model — the communities and the model itself. It's a common data-engineering pattern, and honestly at our scale it's a little more structure than we strictly needed — but it keeps everything traceable, and it's the right way to do it.</a:t>
             </a:r>
           </a:p>
         </p:txBody>
@@ -663,7 +663,7 @@
           <a:lstStyle/>
           <a:p>
             <a:r>
-              <a:t>JONAH (1:30): The ML has two halves. Offline, a nightly job trains K-means on about 1.2 million tracks across ten audio features — danceability, energy, valence, and so on — and produces seven taste communities. It exports a self-describing model artifact — the centroids and the scaler — into gold. Online, when you load a profile, the app builds that user's taste vector from the songs they've played, standardizes it with that same artifact, and finds their nearest community. Compatibility between two people is just the cosine similarity of their taste vectors. Nothing is hardcoded — the app reads whatever the last training run produced.</a:t>
+              <a:t>JONAH (1:30): The model is in two parts. Once a night, we train a clustering model on about 1.2 million songs, using audio features like how danceable or energetic or upbeat a track is — that sorts songs into seven taste communities. Then, when you actually open someone's profile, we take the songs they've played, place them against those communities, and find where they fit. Compatibility between two people is just how close their two taste profiles are. And nothing is hard-coded — if we retrain the model tonight, the app picks up the new version tomorrow. This page is that model's output, live.</a:t>
             </a:r>
           </a:p>
         </p:txBody>
@@ -733,7 +733,7 @@
           <a:lstStyle/>
           <a:p>
             <a:r>
-              <a:t>JONAH (0:45): And we were honest about the limits. The math actually preferred just two clusters, but a persona feature needs more, so we forced seven — and we disclose that, we didn't bury it. We report our real data-coverage numbers. And we originally planned a second model to predict song popularity — we cut it with a written ADR, because no dataset we had could support it honestly, and popularity isn't a stable thing to predict anyway. Cutting it cleanly was the right call. Sebastian will show how this surfaces in the product.</a:t>
+              <a:t>JONAH (0:45): We also want to be upfront about the limits, because we think that matters. The math actually suggested only two groups was cleanest — but two isn't very interesting as 'communities,' so we chose seven on purpose, and we say that openly. Only about a quarter of songs matched our dataset, and we report that honestly rather than hiding it. And we'd planned a second model to predict song popularity, but the data just couldn't support it honestly, so we cut it — and wrote down why. We'd rather show you the real picture than a polished one. Sebastian will show where all this shows up in the app.</a:t>
             </a:r>
           </a:p>
         </p:txBody>
@@ -803,7 +803,7 @@
           <a:lstStyle/>
           <a:p>
             <a:r>
-              <a:t>SEBASTIAN (1:00): The whole frontend is server-rendered pages with a single, consistent theme — dark, quiet, music-native, with a lavender-and-pink accent. Five pages: a landing page, the feed, profiles, an artist studio, and an analytics page. There's no separate JavaScript app to build — the interactivity is lightweight JavaScript talking to the same API, which keeps the whole thing simple and fast to load.</a:t>
+              <a:t>SEBASTIAN (1:00): The whole frontend has one consistent look — dark, calm, music-first, with a lavender-and-pink accent. There are five pages: the landing page, the feed, profiles, an artist studio, and the analytics page. There's no separate app to build — the pages come straight from the same server, with just a bit of JavaScript for the interactive parts. That kept everything fast to load and simple for a small team to keep up with.</a:t>
             </a:r>
           </a:p>
         </p:txBody>
@@ -873,7 +873,7 @@
           <a:lstStyle/>
           <a:p>
             <a:r>
-              <a:t>SEBASTIAN (0:45): The details are what make it feel social. Songs play in place — tap the album art and a Spotify player opens in the card. You get a 'Liked by' line, double-tap to heart like you'd expect, and a one-tap 'share what you're hearing' that reads your current track straight from Spotify. Every empty state has a friendly nudge instead of a blank screen. Let me show you the real thing.</a:t>
+              <a:t>SEBASTIAN (0:45): The small touches are what make it feel like a real social app. Tap the album art and a Spotify player opens right there in the card. There's a 'liked by' line, and you can double-tap to heart a song like you'd expect. There's a one-tap button to share whatever you're playing right now. And every empty screen — no posts yet, nothing playing — has a friendly nudge instead of a blank space. Let me just show you the real thing.</a:t>
             </a:r>
           </a:p>
         </p:txBody>
@@ -943,7 +943,7 @@
           <a:lstStyle/>
           <a:p>
             <a:r>
-              <a:t>SEBASTIAN drives (~2:30). Pre-warm the Render instance so there's no cold-start wait. 1) Landing -&gt; feed: 'here's the live app', scroll, tap album art ('it plays right here'), react and comment. 2) Share: open the composer, use 'share what you're hearing', post it. 3) Profile (Andrea narrates): open another user's profile — streak, top tracks, the taste community, and because it's not me, a compatibility score — both computed live. 4) Analytics (Jonah narrates): seven taste tribes, how distinct they are, each tribe's audio DNA — real numbers from last night's training run. 5) Optional: artist studio. FALLBACK: if the live app misbehaves, cut to the screenshots on the next slides.</a:t>
+              <a:t>SEBASTIAN drives (~2:30). Pre-warm the site so there's no wait. 1) Feed: 'this is the live app' — scroll, tap album art so a song plays in the card, react and drop a comment. 2) Share: use the one-tap 'share what you're playing' and post it. 3) Profile (Andrea narrates): open someone else's profile — their streak, top tracks, their taste community, and since it's not me, a compatibility score, all worked out live. 4) Analytics (Jonah narrates): the seven communities, how distinct they are, and each one's audio DNA — real numbers from last night's run. IF ANYTHING BREAKS: switch to the screenshots on the next slides.</a:t>
             </a:r>
           </a:p>
         </p:txBody>
@@ -1013,7 +1013,7 @@
           <a:lstStyle/>
           <a:p>
             <a:r>
-              <a:t>Demo fallback / static reference: Landing — sign in; your listening becomes the feed</a:t>
+              <a:t>Demo backup / reference: Landing — sign in; your listening becomes the feed</a:t>
             </a:r>
           </a:p>
         </p:txBody>
@@ -1083,7 +1083,7 @@
           <a:lstStyle/>
           <a:p>
             <a:r>
-              <a:t>Demo fallback / static reference: Feed — songs play in place, with reactions &amp; comments</a:t>
+              <a:t>Demo backup / reference: Feed — songs play in place, with reactions &amp; comments</a:t>
             </a:r>
           </a:p>
         </p:txBody>
@@ -1153,7 +1153,7 @@
           <a:lstStyle/>
           <a:p>
             <a:r>
-              <a:t>Demo fallback / static reference: Profile — taste community + % compatible</a:t>
+              <a:t>Demo backup / reference: Profile — taste community + how compatible you are</a:t>
             </a:r>
           </a:p>
         </p:txBody>
@@ -1223,7 +1223,7 @@
           <a:lstStyle/>
           <a:p>
             <a:r>
-              <a:t>Demo fallback / static reference: Artist studio — behind-the-scenes posts</a:t>
+              <a:t>Demo backup / reference: Artist studio — behind-the-scenes posts</a:t>
             </a:r>
           </a:p>
         </p:txBody>
@@ -1293,7 +1293,7 @@
           <a:lstStyle/>
           <a:p>
             <a:r>
-              <a:t>ANDREA (1:00): Social feeds show a curated performance. But your listening history is honest — it's who you actually are musically. Brink turns that into the social object: you share the tracks you're really playing, your friends react and comment, and underneath, machine learning finds the people whose taste genuinely matches yours. Two questions drove the whole build: what do you actually listen to, and who else listens like you.</a:t>
+              <a:t>ANDREA (1:00): The starting point was simple. On most social apps, what you post is a choice — you show the version of yourself you want people to see. Your listening history is different: it's just what you actually played. We thought that was a more honest thing to build a feed around. So on Brink you share the songs you're really listening to, people react and comment, and then we use that listening data to figure out whose taste actually lines up with yours.</a:t>
             </a:r>
           </a:p>
         </p:txBody>
@@ -1363,7 +1363,7 @@
           <a:lstStyle/>
           <a:p>
             <a:r>
-              <a:t>Demo fallback / static reference: Analytics — real model output: tribes &amp; audio DNA</a:t>
+              <a:t>Demo backup / reference: Analytics — the model's real output: communities &amp; audio DNA</a:t>
             </a:r>
           </a:p>
         </p:txBody>
@@ -1433,7 +1433,7 @@
           <a:lstStyle/>
           <a:p>
             <a:r>
-              <a:t>ALL (0:45), one line each. ANDREA: the willingness to pivot the stack twice — early, while it was cheap — is what kept the project reviewable. JONAH: being honest about the model's limits made the analytics more credible, not less. SEBASTIAN: one codebase and one theme meant we moved fast without stepping on each other.</a:t>
+              <a:t>ALL (0:45), one line each. ANDREA: the biggest lesson for me was that the AI was only ever as good as the context and structure we gave it — the planning up front was the whole game. JONAH: being honest about the model's limits made it more convincing, not less. SEBASTIAN: keeping it to one codebase and one consistent look is what let three of us move fast without stepping on each other.</a:t>
             </a:r>
           </a:p>
         </p:txBody>
@@ -1503,7 +1503,7 @@
           <a:lstStyle/>
           <a:p>
             <a:r>
-              <a:t>ANDREA (0:15): That's Brink — live, built, and ours to defend. Thank you. Happy to take questions.</a:t>
+              <a:t>ANDREA (0:15): That's Brink — live, and built by the three of us. Thanks for listening — we're happy to take any questions.</a:t>
             </a:r>
           </a:p>
         </p:txBody>
@@ -1573,7 +1573,7 @@
           <a:lstStyle/>
           <a:p>
             <a:r>
-              <a:t>ANDREA (1:00): Concretely, four things. A feed of songs that play in place, with reactions and comments. A taste community for every user — a cluster our model learns. A compatibility score between any two people. And a lightweight artist portal. Everything you'll see is one live app, fully built. Now the part we're proudest of: HOW three people built and defended this.</a:t>
+              <a:t>ANDREA (1:00): Concretely, Brink is four things. A feed of songs that play right there in the card, with reactions and comments. A taste community for each person — a group our model puts you in. A compatibility score between any two people. And a small artist portal. It's all one live app, and everything we set out to build is built. But the part we actually want to talk about is how three of us built it.</a:t>
             </a:r>
           </a:p>
         </p:txBody>
@@ -1643,7 +1643,7 @@
           <a:lstStyle/>
           <a:p>
             <a:r>
-              <a:t>ANDREA (1:30): This is a management program, so process matters as much as code — and we treated it as a feature. Three numbers: 16 architecture decision records, 82 completed tickets each tied to a requirement, and about 320 automated tests. The guiding principle behind all of it: we only build things we can own and defend. That one idea explains almost every decision, and it's why we made two big pivots you'll see in a moment.</a:t>
+              <a:t>ANDREA (1:30): Honestly, one of our real goals on this project was to see how far we could get by leaning on AI coding agents — to build as much as we possibly could as a team of three. And what we learned early is that AI is only as good as the context you give it. If you're vague, you get vague. So the whole job became two things: give the agents as much context as possible, and be really precise about exactly what we wanted built. That's why our first couple of weeks weren't spent writing app code at all — we were setting up what we call our ADRs, our tickets, and our project governance. That planning is what made everything afterwards move fast.</a:t>
             </a:r>
           </a:p>
         </p:txBody>
@@ -1713,7 +1713,7 @@
           <a:lstStyle/>
           <a:p>
             <a:r>
-              <a:t>ANDREA (1:30): Our workflow has three gates. Decide: every architectural choice is a written ADR — append-only, so to change our minds we supersede rather than edit, and the reasoning never goes stale. Scope: every change is one ticket, one pull request, traced to a requirement — no scope creep. Enforce: CI runs the tests and a secret scan on every PR, plus a custom docs-sync gate — if you change code but not its docs, the build fails. You cannot merge stale documentation. That's how the paper trail stayed honest with three people moving fast.</a:t>
+              <a:t>ANDREA (1:30): So what does that scaffolding actually look like. ADRs are architecture decision records — every real decision written down with the reasoning behind it, so anyone picking up the work, an agent or one of us, knows why things are the way they are. Tickets break the work into one clear piece at a time, so the agent builds exactly that and nothing else. And governance is the guardrails — every change is a pull request, tests and a secret-scanner run automatically, and we even have a check that fails if you change code without updating its docs. All of that is context and clarity — which is exactly what the agents needed to be useful.</a:t>
             </a:r>
           </a:p>
         </p:txBody>
@@ -1783,7 +1783,7 @@
           <a:lstStyle/>
           <a:p>
             <a:r>
-              <a:t>ANDREA (1:00): Two pivots, both from the same principle. We started on a TypeScript backend and a separate React frontend. But security-critical code — auth, token encryption — in a language not everyone could review is a liability for a graded project. So we moved the backend to Python/FastAPI, then retired the React app for server-rendered pages. The end state: one Python codebase every one of us can read, review, and defend. Both decisions are ADRs.</a:t>
+              <a:t>ANDREA (1:00): There were two moments where we changed our minds, and they're worth sharing because the reasoning was the same both times. We started the backend in TypeScript and the frontend as a separate React app. But the security-sensitive parts — logins, encrypting people's tokens — were in a stack not all three of us could confidently read. For a graded project, that's a real risk. So we moved the backend to Python, and later replaced the React app with simpler server-rendered pages. Now it's one Python codebase all of us can read and defend. Both of those are written up as ADRs, so you can see the reasoning.</a:t>
             </a:r>
           </a:p>
         </p:txBody>
@@ -1853,7 +1853,7 @@
           <a:lstStyle/>
           <a:p>
             <a:r>
-              <a:t>ANDREA (1:00): The whole product is one FastAPI app on Render. It serves the JSON API and the HTML pages, same-origin — no CORS, no separate build. Supabase gives us Postgres, auth, and file storage. And a separate Python analytics job runs nightly on GitHub Actions, trains our model, and writes results back into the same database, which the app reads on the fly. Simple, cheap, entirely on free tiers.</a:t>
+              <a:t>ANDREA (1:00): Here's how it all fits together. Everything the user touches is one app — a FastAPI service on Render that serves both the web pages and the API, so there's no separate frontend to deploy. It talks to Supabase for the database, logins, and file storage. Off to the side, a Python job runs every night on GitHub Actions, trains our model, and writes the results into the database — and the app just reads those results when someone loads a page. And Spotify is where the logins and the listening data come from.</a:t>
             </a:r>
           </a:p>
         </p:txBody>
@@ -1923,7 +1923,7 @@
           <a:lstStyle/>
           <a:p>
             <a:r>
-              <a:t>ANDREA (1:00): About 14 tables. The social side is what you'd expect — users, posts, reactions, comments, the follow graph. The interesting part is that the analytics tables live in their own medallion schemas — bronze, silver, gold — right alongside the social data in one Postgres. Jonah will explain why. One nice detail: a user's cluster and compatibility aren't stored — they're computed on read, so they're never stale.</a:t>
+              <a:t>ANDREA (0:50): Behind it is about 14 tables. The social side is what you'd expect — users, posts, reactions, comments, who follows whom. The music side holds the tracks, everyone's plays, and the taste communities the model produces. One thing we're a little proud of: a person's community and their compatibility with you aren't saved anywhere — we work them out on the spot when you load the page, so they're never out of date.</a:t>
             </a:r>
           </a:p>
         </p:txBody>
@@ -1993,7 +1993,7 @@
           <a:lstStyle/>
           <a:p>
             <a:r>
-              <a:t>ANDREA (0:45): Security was the reason for the Python pivot, so we take it seriously. We validate Supabase tokens server-side and never hold a JWT secret. We own long-term Spotify access by storing the refresh token encrypted with AES-256-GCM. Writes are rate-limited per user, and a secret scanner runs on every commit locally and in CI. Over to Jonah for the analytics.</a:t>
+              <a:t>ANDREA (0:45): On security — we validate every login on our own server and never hold a master secret. The tokens we keep for Spotify are encrypted before they ever touch the database. There are limits on how fast anyone can post, and a scanner runs on every single commit to make sure we never accidentally check in a password or key. Security was the reason we moved to Python in the first place, so we didn't cut corners here. I'll hand over to Jonah for the analytics.</a:t>
             </a:r>
           </a:p>
         </p:txBody>
@@ -5074,7 +5074,7 @@
           <a:lstStyle/>
           <a:p>
             <a:r>
-              <a:rPr sz="5200" b="1" i="0">
+              <a:rPr sz="5000" b="1" i="0">
                 <a:solidFill>
                   <a:srgbClr val="EDEDF5"/>
                 </a:solidFill>
@@ -5093,7 +5093,7 @@
         </p:nvSpPr>
         <p:spPr>
           <a:xfrm>
-            <a:off x="822960" y="3794760"/>
+            <a:off x="822960" y="3749039"/>
             <a:ext cx="10515600" cy="914400"/>
           </a:xfrm>
           <a:prstGeom prst="rect">
@@ -5114,7 +5114,7 @@
                 </a:solidFill>
                 <a:latin typeface="Inter"/>
               </a:rPr>
-              <a:t>A social network built on your real listening.</a:t>
+              <a:t>A social app built on what you actually listen to.</a:t>
             </a:r>
           </a:p>
         </p:txBody>
@@ -5127,7 +5127,7 @@
         </p:nvSpPr>
         <p:spPr>
           <a:xfrm>
-            <a:off x="822960" y="4754880"/>
+            <a:off x="822960" y="4709160"/>
             <a:ext cx="10515600" cy="1280160"/>
           </a:xfrm>
           <a:prstGeom prst="rect">
@@ -5244,7 +5244,7 @@
         <p:spPr>
           <a:xfrm>
             <a:off x="640080" y="868680"/>
-            <a:ext cx="10881360" cy="1188720"/>
+            <a:ext cx="10881360" cy="1280160"/>
           </a:xfrm>
           <a:prstGeom prst="rect">
             <a:avLst/>
@@ -5258,13 +5258,13 @@
           <a:lstStyle/>
           <a:p>
             <a:r>
-              <a:rPr sz="3400" b="1" i="0">
+              <a:rPr sz="3200" b="1" i="0">
                 <a:solidFill>
                   <a:srgbClr val="9D8DF1"/>
                 </a:solidFill>
                 <a:latin typeface="Inter"/>
               </a:rPr>
-              <a:t>The data engineering: a medallion</a:t>
+              <a:t>How the data is organised</a:t>
             </a:r>
           </a:p>
         </p:txBody>
@@ -5277,8 +5277,8 @@
         </p:nvSpPr>
         <p:spPr>
           <a:xfrm>
-            <a:off x="658368" y="1965960"/>
-            <a:ext cx="1463040" cy="38100"/>
+            <a:off x="658368" y="2011680"/>
+            <a:ext cx="1371600" cy="38100"/>
           </a:xfrm>
           <a:prstGeom prst="rect">
             <a:avLst/>
@@ -5321,7 +5321,7 @@
         </p:nvSpPr>
         <p:spPr>
           <a:xfrm>
-            <a:off x="640080" y="2331720"/>
+            <a:off x="640080" y="2377440"/>
             <a:ext cx="10881360" cy="4023360"/>
           </a:xfrm>
           <a:prstGeom prst="rect">
@@ -5337,7 +5337,7 @@
           <a:p>
             <a:pPr>
               <a:spcAft>
-                <a:spcPts val="1200"/>
+                <a:spcPts val="1400"/>
               </a:spcAft>
             </a:pPr>
             <a:r>
@@ -5347,13 +5347,13 @@
                 </a:solidFill>
                 <a:latin typeface="Inter"/>
               </a:rPr>
-              <a:t>Bronze  —  raw, immutable landings (Spotify pulls, raw Kaggle rows)</a:t>
+              <a:t>Raw — everything exactly as it arrives (Spotify pulls, dataset rows)</a:t>
             </a:r>
           </a:p>
           <a:p>
             <a:pPr>
               <a:spcAft>
-                <a:spcPts val="1200"/>
+                <a:spcPts val="1400"/>
               </a:spcAft>
             </a:pPr>
             <a:r>
@@ -5363,13 +5363,13 @@
                 </a:solidFill>
                 <a:latin typeface="Inter"/>
               </a:rPr>
-              <a:t>Silver  —  cleaned, conformed data the app uses (Track, Play)</a:t>
+              <a:t>Cleaned — tidied into the tables the app actually uses</a:t>
             </a:r>
           </a:p>
           <a:p>
             <a:pPr>
               <a:spcAft>
-                <a:spcPts val="1200"/>
+                <a:spcPts val="1400"/>
               </a:spcAft>
             </a:pPr>
             <a:r>
@@ -5379,13 +5379,13 @@
                 </a:solidFill>
                 <a:latin typeface="Inter"/>
               </a:rPr>
-              <a:t>Gold  —  model output (clusters, metrics, the trained model itself)</a:t>
+              <a:t>Model output — the communities and the trained model itself</a:t>
             </a:r>
           </a:p>
           <a:p>
             <a:pPr>
               <a:spcAft>
-                <a:spcPts val="1200"/>
+                <a:spcPts val="1400"/>
               </a:spcAft>
             </a:pPr>
             <a:r>
@@ -5395,7 +5395,23 @@
                 </a:solidFill>
                 <a:latin typeface="Inter"/>
               </a:rPr>
-              <a:t>•  All on free Postgres — no Spark, no lakehouse. Right-sized, with legible lineage.</a:t>
+              <a:t>•  It's a standard 'medallion' pattern. A bit more structure than we strictly needed —</a:t>
+            </a:r>
+          </a:p>
+          <a:p>
+            <a:pPr>
+              <a:spcAft>
+                <a:spcPts val="1400"/>
+              </a:spcAft>
+            </a:pPr>
+            <a:r>
+              <a:rPr sz="2000" b="0" i="0">
+                <a:solidFill>
+                  <a:srgbClr val="EDEDF5"/>
+                </a:solidFill>
+                <a:latin typeface="Inter"/>
+              </a:rPr>
+              <a:t>•  but everything stays traceable, which is the point.</a:t>
             </a:r>
           </a:p>
         </p:txBody>
@@ -5469,7 +5485,7 @@
         <p:spPr>
           <a:xfrm>
             <a:off x="640080" y="868680"/>
-            <a:ext cx="10881360" cy="1188720"/>
+            <a:ext cx="6400800" cy="1280160"/>
           </a:xfrm>
           <a:prstGeom prst="rect">
             <a:avLst/>
@@ -5483,13 +5499,13 @@
           <a:lstStyle/>
           <a:p>
             <a:r>
-              <a:rPr sz="3400" b="1" i="0">
+              <a:rPr sz="3200" b="1" i="0">
                 <a:solidFill>
                   <a:srgbClr val="9D8DF1"/>
                 </a:solidFill>
                 <a:latin typeface="Inter"/>
               </a:rPr>
-              <a:t>The ML: K-means + on-read inference</a:t>
+              <a:t>The model, in two parts</a:t>
             </a:r>
           </a:p>
         </p:txBody>
@@ -5502,8 +5518,8 @@
         </p:nvSpPr>
         <p:spPr>
           <a:xfrm>
-            <a:off x="658368" y="1965960"/>
-            <a:ext cx="1463040" cy="38100"/>
+            <a:off x="658368" y="2011680"/>
+            <a:ext cx="1371600" cy="38100"/>
           </a:xfrm>
           <a:prstGeom prst="rect">
             <a:avLst/>
@@ -5546,8 +5562,8 @@
         </p:nvSpPr>
         <p:spPr>
           <a:xfrm>
-            <a:off x="640080" y="2331720"/>
-            <a:ext cx="10881360" cy="4023360"/>
+            <a:off x="640080" y="2377440"/>
+            <a:ext cx="5760720" cy="4023360"/>
           </a:xfrm>
           <a:prstGeom prst="rect">
             <a:avLst/>
@@ -5562,69 +5578,171 @@
           <a:p>
             <a:pPr>
               <a:spcAft>
-                <a:spcPts val="1200"/>
+                <a:spcPts val="1400"/>
               </a:spcAft>
             </a:pPr>
             <a:r>
-              <a:rPr sz="2000" b="1" i="0">
+              <a:rPr sz="1900" b="1" i="0">
                 <a:solidFill>
                   <a:srgbClr val="F472B6"/>
                 </a:solidFill>
                 <a:latin typeface="Inter"/>
               </a:rPr>
-              <a:t>Offline:  K-means on ~1.2M tracks × 10 audio features → 7 taste communities</a:t>
+              <a:t>Once a night:  we cluster ~1.2M songs by their sound</a:t>
             </a:r>
           </a:p>
           <a:p>
             <a:pPr>
               <a:spcAft>
-                <a:spcPts val="1200"/>
+                <a:spcPts val="1400"/>
               </a:spcAft>
             </a:pPr>
             <a:r>
-              <a:rPr sz="2000" b="0" i="0">
+              <a:rPr sz="1900" b="0" i="0">
                 <a:solidFill>
                   <a:srgbClr val="EDEDF5"/>
                 </a:solidFill>
                 <a:latin typeface="Inter"/>
               </a:rPr>
-              <a:t>•  It exports a self-describing model artifact (centroids + scaler) into gold</a:t>
+              <a:t>•  (danceable, energetic, upbeat…) into 7 taste communities.</a:t>
             </a:r>
           </a:p>
           <a:p>
             <a:pPr>
               <a:spcAft>
-                <a:spcPts val="1200"/>
+                <a:spcPts val="1400"/>
               </a:spcAft>
             </a:pPr>
             <a:r>
-              <a:rPr sz="2000" b="1" i="0">
+              <a:rPr sz="1900" b="1" i="0">
                 <a:solidFill>
                   <a:srgbClr val="F472B6"/>
                 </a:solidFill>
                 <a:latin typeface="Inter"/>
               </a:rPr>
-              <a:t>On read:  build a user's taste vector → nearest community → cosine compatibility</a:t>
+              <a:t>When you open a profile:  we place that person's songs against</a:t>
             </a:r>
           </a:p>
           <a:p>
             <a:pPr>
               <a:spcAft>
-                <a:spcPts val="1200"/>
+                <a:spcPts val="1400"/>
               </a:spcAft>
             </a:pPr>
             <a:r>
-              <a:rPr sz="2000" b="0" i="0">
+              <a:rPr sz="1900" b="0" i="0">
                 <a:solidFill>
                   <a:srgbClr val="EDEDF5"/>
                 </a:solidFill>
                 <a:latin typeface="Inter"/>
               </a:rPr>
-              <a:t>•  Nothing is hardcoded — the app reads whatever the last training run produced.</a:t>
-            </a:r>
-          </a:p>
-        </p:txBody>
-      </p:sp>
+              <a:t>•  the communities and find where they fit.</a:t>
+            </a:r>
+          </a:p>
+          <a:p>
+            <a:pPr>
+              <a:spcAft>
+                <a:spcPts val="1400"/>
+              </a:spcAft>
+            </a:pPr>
+            <a:r>
+              <a:rPr sz="1900" b="0" i="0">
+                <a:solidFill>
+                  <a:srgbClr val="EDEDF5"/>
+                </a:solidFill>
+                <a:latin typeface="Inter"/>
+              </a:rPr>
+              <a:t>•  Compatibility = how close two people's taste profiles are.</a:t>
+            </a:r>
+          </a:p>
+          <a:p>
+            <a:pPr>
+              <a:spcAft>
+                <a:spcPts val="1400"/>
+              </a:spcAft>
+            </a:pPr>
+            <a:r>
+              <a:rPr sz="1900" b="0" i="0">
+                <a:solidFill>
+                  <a:srgbClr val="EDEDF5"/>
+                </a:solidFill>
+                <a:latin typeface="Inter"/>
+              </a:rPr>
+              <a:t>•  Nothing's hard-coded — retrain tonight, the app updates tomorrow.</a:t>
+            </a:r>
+          </a:p>
+        </p:txBody>
+      </p:sp>
+      <p:sp>
+        <p:nvSpPr>
+          <p:cNvPr id="6" name="Rounded Rectangle 5"/>
+          <p:cNvSpPr/>
+          <p:nvPr/>
+        </p:nvSpPr>
+        <p:spPr>
+          <a:xfrm>
+            <a:off x="6720840" y="914400"/>
+            <a:ext cx="4846320" cy="5394960"/>
+          </a:xfrm>
+          <a:prstGeom prst="roundRect">
+            <a:avLst/>
+          </a:prstGeom>
+          <a:solidFill>
+            <a:srgbClr val="15151F"/>
+          </a:solidFill>
+          <a:ln w="12700">
+            <a:solidFill>
+              <a:srgbClr val="2E2E44"/>
+            </a:solidFill>
+          </a:ln>
+          <a:effectLst/>
+        </p:spPr>
+        <p:style>
+          <a:lnRef idx="1">
+            <a:schemeClr val="accent1"/>
+          </a:lnRef>
+          <a:fillRef idx="3">
+            <a:schemeClr val="accent1"/>
+          </a:fillRef>
+          <a:effectRef idx="2">
+            <a:schemeClr val="accent1"/>
+          </a:effectRef>
+          <a:fontRef idx="minor">
+            <a:schemeClr val="lt1"/>
+          </a:fontRef>
+        </p:style>
+        <p:txBody>
+          <a:bodyPr rtlCol="0" anchor="ctr"/>
+          <a:lstStyle/>
+          <a:p>
+            <a:pPr algn="ctr"/>
+          </a:p>
+        </p:txBody>
+      </p:sp>
+      <p:pic>
+        <p:nvPicPr>
+          <p:cNvPr id="7" name="Picture 6" descr="analytics-brink.png"/>
+          <p:cNvPicPr>
+            <a:picLocks noChangeAspect="1"/>
+          </p:cNvPicPr>
+          <p:nvPr/>
+        </p:nvPicPr>
+        <p:blipFill>
+          <a:blip r:embed="rId2"/>
+          <a:stretch>
+            <a:fillRect/>
+          </a:stretch>
+        </p:blipFill>
+        <p:spPr>
+          <a:xfrm>
+            <a:off x="7318651" y="1051560"/>
+            <a:ext cx="3650698" cy="5120640"/>
+          </a:xfrm>
+          <a:prstGeom prst="rect">
+            <a:avLst/>
+          </a:prstGeom>
+        </p:spPr>
+      </p:pic>
     </p:spTree>
   </p:cSld>
   <p:clrMapOvr>
@@ -5694,7 +5812,7 @@
         <p:spPr>
           <a:xfrm>
             <a:off x="640080" y="868680"/>
-            <a:ext cx="10881360" cy="1188720"/>
+            <a:ext cx="10881360" cy="1280160"/>
           </a:xfrm>
           <a:prstGeom prst="rect">
             <a:avLst/>
@@ -5708,13 +5826,13 @@
           <a:lstStyle/>
           <a:p>
             <a:r>
-              <a:rPr sz="3400" b="1" i="0">
+              <a:rPr sz="3200" b="1" i="0">
                 <a:solidFill>
                   <a:srgbClr val="9D8DF1"/>
                 </a:solidFill>
                 <a:latin typeface="Inter"/>
               </a:rPr>
-              <a:t>Honesty about the limits</a:t>
+              <a:t>Being honest about the limits</a:t>
             </a:r>
           </a:p>
         </p:txBody>
@@ -5727,8 +5845,8 @@
         </p:nvSpPr>
         <p:spPr>
           <a:xfrm>
-            <a:off x="658368" y="1965960"/>
-            <a:ext cx="1463040" cy="38100"/>
+            <a:off x="658368" y="2011680"/>
+            <a:ext cx="1371600" cy="38100"/>
           </a:xfrm>
           <a:prstGeom prst="rect">
             <a:avLst/>
@@ -5771,7 +5889,7 @@
         </p:nvSpPr>
         <p:spPr>
           <a:xfrm>
-            <a:off x="640080" y="2331720"/>
+            <a:off x="640080" y="2377440"/>
             <a:ext cx="10881360" cy="4023360"/>
           </a:xfrm>
           <a:prstGeom prst="rect">
@@ -5787,39 +5905,39 @@
           <a:p>
             <a:pPr>
               <a:spcAft>
-                <a:spcPts val="1200"/>
+                <a:spcPts val="1400"/>
               </a:spcAft>
             </a:pPr>
             <a:r>
-              <a:rPr sz="2000" b="1" i="0">
-                <a:solidFill>
-                  <a:srgbClr val="F472B6"/>
-                </a:solidFill>
-                <a:latin typeface="Inter"/>
-              </a:rPr>
-              <a:t>Forced k=7  —  the math preferred k=2; a persona feature needs more, so we disclose it</a:t>
+              <a:rPr sz="2000" b="0" i="0">
+                <a:solidFill>
+                  <a:srgbClr val="EDEDF5"/>
+                </a:solidFill>
+                <a:latin typeface="Inter"/>
+              </a:rPr>
+              <a:t>•  The math actually liked just 2 groups — we chose 7 on purpose, and we say so.</a:t>
             </a:r>
           </a:p>
           <a:p>
             <a:pPr>
               <a:spcAft>
-                <a:spcPts val="1200"/>
+                <a:spcPts val="1400"/>
               </a:spcAft>
             </a:pPr>
             <a:r>
-              <a:rPr sz="2000" b="1" i="0">
-                <a:solidFill>
-                  <a:srgbClr val="F472B6"/>
-                </a:solidFill>
-                <a:latin typeface="Inter"/>
-              </a:rPr>
-              <a:t>~24% dataset coverage  —  logged, not hidden</a:t>
+              <a:rPr sz="2000" b="0" i="0">
+                <a:solidFill>
+                  <a:srgbClr val="EDEDF5"/>
+                </a:solidFill>
+                <a:latin typeface="Inter"/>
+              </a:rPr>
+              <a:t>•  Only ~a quarter of songs matched our dataset — we report that, we don't hide it.</a:t>
             </a:r>
           </a:p>
           <a:p>
             <a:pPr>
               <a:spcAft>
-                <a:spcPts val="1200"/>
+                <a:spcPts val="1400"/>
               </a:spcAft>
             </a:pPr>
             <a:r>
@@ -5829,13 +5947,13 @@
                 </a:solidFill>
                 <a:latin typeface="Inter"/>
               </a:rPr>
-              <a:t>Second model (popularity) CUT  —  ADR-0016: no dataset supported it honestly</a:t>
+              <a:t>We planned a second model (song popularity) and cut it — the data couldn't support it.</a:t>
             </a:r>
           </a:p>
           <a:p>
             <a:pPr>
               <a:spcAft>
-                <a:spcPts val="1200"/>
+                <a:spcPts val="1400"/>
               </a:spcAft>
             </a:pPr>
             <a:r>
@@ -5845,7 +5963,7 @@
                 </a:solidFill>
                 <a:latin typeface="Inter"/>
               </a:rPr>
-              <a:t>•  Cutting it cleanly was the right engineering call.</a:t>
+              <a:t>•  We wrote down why. We'd rather show the real picture than a polished one.</a:t>
             </a:r>
           </a:p>
         </p:txBody>
@@ -5919,7 +6037,7 @@
         <p:spPr>
           <a:xfrm>
             <a:off x="640080" y="868680"/>
-            <a:ext cx="10881360" cy="1188720"/>
+            <a:ext cx="6400800" cy="1280160"/>
           </a:xfrm>
           <a:prstGeom prst="rect">
             <a:avLst/>
@@ -5933,13 +6051,13 @@
           <a:lstStyle/>
           <a:p>
             <a:r>
-              <a:rPr sz="3400" b="1" i="0">
+              <a:rPr sz="3200" b="1" i="0">
                 <a:solidFill>
                   <a:srgbClr val="9D8DF1"/>
                 </a:solidFill>
                 <a:latin typeface="Inter"/>
               </a:rPr>
-              <a:t>One theme, five pages</a:t>
+              <a:t>One look, five pages</a:t>
             </a:r>
           </a:p>
         </p:txBody>
@@ -5952,8 +6070,8 @@
         </p:nvSpPr>
         <p:spPr>
           <a:xfrm>
-            <a:off x="658368" y="1965960"/>
-            <a:ext cx="1463040" cy="38100"/>
+            <a:off x="658368" y="2011680"/>
+            <a:ext cx="1371600" cy="38100"/>
           </a:xfrm>
           <a:prstGeom prst="rect">
             <a:avLst/>
@@ -5996,8 +6114,8 @@
         </p:nvSpPr>
         <p:spPr>
           <a:xfrm>
-            <a:off x="640080" y="2331720"/>
-            <a:ext cx="10881360" cy="4023360"/>
+            <a:off x="640080" y="2377440"/>
+            <a:ext cx="5760720" cy="4023360"/>
           </a:xfrm>
           <a:prstGeom prst="rect">
             <a:avLst/>
@@ -6012,69 +6130,155 @@
           <a:p>
             <a:pPr>
               <a:spcAft>
-                <a:spcPts val="1200"/>
+                <a:spcPts val="1400"/>
               </a:spcAft>
             </a:pPr>
             <a:r>
-              <a:rPr sz="2000" b="0" i="0">
+              <a:rPr sz="1900" b="0" i="0">
                 <a:solidFill>
                   <a:srgbClr val="EDEDF5"/>
                 </a:solidFill>
                 <a:latin typeface="Inter"/>
               </a:rPr>
-              <a:t>•  Server-rendered pages — no separate JS app to build; lightweight JS calls the same API</a:t>
+              <a:t>•  Dark, calm, music-first — a lavender &amp; pink accent throughout.</a:t>
             </a:r>
           </a:p>
           <a:p>
             <a:pPr>
               <a:spcAft>
-                <a:spcPts val="1200"/>
+                <a:spcPts val="1400"/>
               </a:spcAft>
             </a:pPr>
             <a:r>
-              <a:rPr sz="2000" b="0" i="0">
-                <a:solidFill>
-                  <a:srgbClr val="EDEDF5"/>
-                </a:solidFill>
-                <a:latin typeface="Inter"/>
-              </a:rPr>
-              <a:t>•  Dark, quiet, music-native — a lavender &amp; hot-pink accent throughout</a:t>
+              <a:rPr sz="1900" b="1" i="0">
+                <a:solidFill>
+                  <a:srgbClr val="F472B6"/>
+                </a:solidFill>
+                <a:latin typeface="Inter"/>
+              </a:rPr>
+              <a:t>Landing · Feed · Profile · Artist studio · Analytics</a:t>
             </a:r>
           </a:p>
           <a:p>
             <a:pPr>
               <a:spcAft>
-                <a:spcPts val="1200"/>
+                <a:spcPts val="1400"/>
               </a:spcAft>
             </a:pPr>
             <a:r>
-              <a:rPr sz="2000" b="1" i="0">
-                <a:solidFill>
-                  <a:srgbClr val="F472B6"/>
-                </a:solidFill>
-                <a:latin typeface="Inter"/>
-              </a:rPr>
-              <a:t>Landing · Feed · Profile · Artist studio · Analytics</a:t>
+              <a:rPr sz="1900" b="0" i="0">
+                <a:solidFill>
+                  <a:srgbClr val="EDEDF5"/>
+                </a:solidFill>
+                <a:latin typeface="Inter"/>
+              </a:rPr>
+              <a:t>•  No separate app to build — the pages come from the same server,</a:t>
             </a:r>
           </a:p>
           <a:p>
             <a:pPr>
               <a:spcAft>
-                <a:spcPts val="1200"/>
+                <a:spcPts val="1400"/>
               </a:spcAft>
             </a:pPr>
             <a:r>
-              <a:rPr sz="2000" b="0" i="0">
+              <a:rPr sz="1900" b="0" i="0">
                 <a:solidFill>
                   <a:srgbClr val="EDEDF5"/>
                 </a:solidFill>
                 <a:latin typeface="Inter"/>
               </a:rPr>
-              <a:t>•  Fast to load, consistent, and simple for a small team to maintain.</a:t>
-            </a:r>
-          </a:p>
-        </p:txBody>
-      </p:sp>
+              <a:t>•  with light JavaScript for the interactive bits.</a:t>
+            </a:r>
+          </a:p>
+          <a:p>
+            <a:pPr>
+              <a:spcAft>
+                <a:spcPts val="1400"/>
+              </a:spcAft>
+            </a:pPr>
+            <a:r>
+              <a:rPr sz="1900" b="0" i="0">
+                <a:solidFill>
+                  <a:srgbClr val="EDEDF5"/>
+                </a:solidFill>
+                <a:latin typeface="Inter"/>
+              </a:rPr>
+              <a:t>•  That kept it fast, and simple for a small team to maintain.</a:t>
+            </a:r>
+          </a:p>
+        </p:txBody>
+      </p:sp>
+      <p:sp>
+        <p:nvSpPr>
+          <p:cNvPr id="6" name="Rounded Rectangle 5"/>
+          <p:cNvSpPr/>
+          <p:nvPr/>
+        </p:nvSpPr>
+        <p:spPr>
+          <a:xfrm>
+            <a:off x="6720840" y="914400"/>
+            <a:ext cx="4846320" cy="5394960"/>
+          </a:xfrm>
+          <a:prstGeom prst="roundRect">
+            <a:avLst/>
+          </a:prstGeom>
+          <a:solidFill>
+            <a:srgbClr val="15151F"/>
+          </a:solidFill>
+          <a:ln w="12700">
+            <a:solidFill>
+              <a:srgbClr val="2E2E44"/>
+            </a:solidFill>
+          </a:ln>
+          <a:effectLst/>
+        </p:spPr>
+        <p:style>
+          <a:lnRef idx="1">
+            <a:schemeClr val="accent1"/>
+          </a:lnRef>
+          <a:fillRef idx="3">
+            <a:schemeClr val="accent1"/>
+          </a:fillRef>
+          <a:effectRef idx="2">
+            <a:schemeClr val="accent1"/>
+          </a:effectRef>
+          <a:fontRef idx="minor">
+            <a:schemeClr val="lt1"/>
+          </a:fontRef>
+        </p:style>
+        <p:txBody>
+          <a:bodyPr rtlCol="0" anchor="ctr"/>
+          <a:lstStyle/>
+          <a:p>
+            <a:pPr algn="ctr"/>
+          </a:p>
+        </p:txBody>
+      </p:sp>
+      <p:pic>
+        <p:nvPicPr>
+          <p:cNvPr id="7" name="Picture 6" descr="Landing-brink.png"/>
+          <p:cNvPicPr>
+            <a:picLocks noChangeAspect="1"/>
+          </p:cNvPicPr>
+          <p:nvPr/>
+        </p:nvPicPr>
+        <p:blipFill>
+          <a:blip r:embed="rId2"/>
+          <a:stretch>
+            <a:fillRect/>
+          </a:stretch>
+        </p:blipFill>
+        <p:spPr>
+          <a:xfrm>
+            <a:off x="7309792" y="1051560"/>
+            <a:ext cx="3668415" cy="5120640"/>
+          </a:xfrm>
+          <a:prstGeom prst="rect">
+            <a:avLst/>
+          </a:prstGeom>
+        </p:spPr>
+      </p:pic>
     </p:spTree>
   </p:cSld>
   <p:clrMapOvr>
@@ -6144,7 +6348,7 @@
         <p:spPr>
           <a:xfrm>
             <a:off x="640080" y="868680"/>
-            <a:ext cx="10881360" cy="1188720"/>
+            <a:ext cx="6400800" cy="1280160"/>
           </a:xfrm>
           <a:prstGeom prst="rect">
             <a:avLst/>
@@ -6158,13 +6362,13 @@
           <a:lstStyle/>
           <a:p>
             <a:r>
-              <a:rPr sz="3400" b="1" i="0">
+              <a:rPr sz="3200" b="1" i="0">
                 <a:solidFill>
                   <a:srgbClr val="9D8DF1"/>
                 </a:solidFill>
                 <a:latin typeface="Inter"/>
               </a:rPr>
-              <a:t>The social details</a:t>
+              <a:t>The small touches</a:t>
             </a:r>
           </a:p>
         </p:txBody>
@@ -6177,8 +6381,8 @@
         </p:nvSpPr>
         <p:spPr>
           <a:xfrm>
-            <a:off x="658368" y="1965960"/>
-            <a:ext cx="1463040" cy="38100"/>
+            <a:off x="658368" y="2011680"/>
+            <a:ext cx="1371600" cy="38100"/>
           </a:xfrm>
           <a:prstGeom prst="rect">
             <a:avLst/>
@@ -6221,8 +6425,8 @@
         </p:nvSpPr>
         <p:spPr>
           <a:xfrm>
-            <a:off x="640080" y="2331720"/>
-            <a:ext cx="10881360" cy="4023360"/>
+            <a:off x="640080" y="2377440"/>
+            <a:ext cx="5760720" cy="4023360"/>
           </a:xfrm>
           <a:prstGeom prst="rect">
             <a:avLst/>
@@ -6237,69 +6441,139 @@
           <a:p>
             <a:pPr>
               <a:spcAft>
-                <a:spcPts val="1200"/>
+                <a:spcPts val="1400"/>
               </a:spcAft>
             </a:pPr>
             <a:r>
-              <a:rPr sz="2000" b="1" i="0">
+              <a:rPr sz="1900" b="1" i="0">
                 <a:solidFill>
                   <a:srgbClr val="F472B6"/>
                 </a:solidFill>
                 <a:latin typeface="Inter"/>
               </a:rPr>
-              <a:t>Play-in-place  —  tap album art, a Spotify player opens in the card</a:t>
+              <a:t>Tap the album art — a Spotify player opens right in the card.</a:t>
             </a:r>
           </a:p>
           <a:p>
             <a:pPr>
               <a:spcAft>
-                <a:spcPts val="1200"/>
+                <a:spcPts val="1400"/>
               </a:spcAft>
             </a:pPr>
             <a:r>
-              <a:rPr sz="2000" b="1" i="0">
+              <a:rPr sz="1900" b="1" i="0">
                 <a:solidFill>
                   <a:srgbClr val="F472B6"/>
                 </a:solidFill>
                 <a:latin typeface="Inter"/>
               </a:rPr>
-              <a:t>Liked by X and N others  ·  double-tap-to-heart</a:t>
+              <a:t>A 'liked by' line, and double-tap to heart, like you'd expect.</a:t>
             </a:r>
           </a:p>
           <a:p>
             <a:pPr>
               <a:spcAft>
-                <a:spcPts val="1200"/>
+                <a:spcPts val="1400"/>
               </a:spcAft>
             </a:pPr>
             <a:r>
-              <a:rPr sz="2000" b="1" i="0">
+              <a:rPr sz="1900" b="1" i="0">
                 <a:solidFill>
                   <a:srgbClr val="F472B6"/>
                 </a:solidFill>
                 <a:latin typeface="Inter"/>
               </a:rPr>
-              <a:t>One-tap 'share what you're hearing'  —  reads your current track from Spotify</a:t>
+              <a:t>One tap to share whatever you're playing right now.</a:t>
             </a:r>
           </a:p>
           <a:p>
             <a:pPr>
               <a:spcAft>
-                <a:spcPts val="1200"/>
+                <a:spcPts val="1400"/>
               </a:spcAft>
             </a:pPr>
             <a:r>
-              <a:rPr sz="2000" b="0" i="0">
+              <a:rPr sz="1900" b="0" i="0">
                 <a:solidFill>
                   <a:srgbClr val="EDEDF5"/>
                 </a:solidFill>
                 <a:latin typeface="Inter"/>
               </a:rPr>
-              <a:t>•  Every empty state has a friendly nudge, not a blank screen.</a:t>
-            </a:r>
-          </a:p>
-        </p:txBody>
-      </p:sp>
+              <a:t>•  Every empty screen has a friendly nudge, not a blank space.</a:t>
+            </a:r>
+          </a:p>
+        </p:txBody>
+      </p:sp>
+      <p:sp>
+        <p:nvSpPr>
+          <p:cNvPr id="6" name="Rounded Rectangle 5"/>
+          <p:cNvSpPr/>
+          <p:nvPr/>
+        </p:nvSpPr>
+        <p:spPr>
+          <a:xfrm>
+            <a:off x="6720840" y="914400"/>
+            <a:ext cx="4846320" cy="5394960"/>
+          </a:xfrm>
+          <a:prstGeom prst="roundRect">
+            <a:avLst/>
+          </a:prstGeom>
+          <a:solidFill>
+            <a:srgbClr val="15151F"/>
+          </a:solidFill>
+          <a:ln w="12700">
+            <a:solidFill>
+              <a:srgbClr val="2E2E44"/>
+            </a:solidFill>
+          </a:ln>
+          <a:effectLst/>
+        </p:spPr>
+        <p:style>
+          <a:lnRef idx="1">
+            <a:schemeClr val="accent1"/>
+          </a:lnRef>
+          <a:fillRef idx="3">
+            <a:schemeClr val="accent1"/>
+          </a:fillRef>
+          <a:effectRef idx="2">
+            <a:schemeClr val="accent1"/>
+          </a:effectRef>
+          <a:fontRef idx="minor">
+            <a:schemeClr val="lt1"/>
+          </a:fontRef>
+        </p:style>
+        <p:txBody>
+          <a:bodyPr rtlCol="0" anchor="ctr"/>
+          <a:lstStyle/>
+          <a:p>
+            <a:pPr algn="ctr"/>
+          </a:p>
+        </p:txBody>
+      </p:sp>
+      <p:pic>
+        <p:nvPicPr>
+          <p:cNvPr id="7" name="Picture 6" descr="Profile-brink.png"/>
+          <p:cNvPicPr>
+            <a:picLocks noChangeAspect="1"/>
+          </p:cNvPicPr>
+          <p:nvPr/>
+        </p:nvPicPr>
+        <p:blipFill>
+          <a:blip r:embed="rId2"/>
+          <a:stretch>
+            <a:fillRect/>
+          </a:stretch>
+        </p:blipFill>
+        <p:spPr>
+          <a:xfrm>
+            <a:off x="7330440" y="1051560"/>
+            <a:ext cx="3627120" cy="5120640"/>
+          </a:xfrm>
+          <a:prstGeom prst="rect">
+            <a:avLst/>
+          </a:prstGeom>
+        </p:spPr>
+      </p:pic>
     </p:spTree>
   </p:cSld>
   <p:clrMapOvr>
@@ -6369,7 +6643,7 @@
         <p:spPr>
           <a:xfrm>
             <a:off x="640080" y="868680"/>
-            <a:ext cx="10881360" cy="1188720"/>
+            <a:ext cx="10881360" cy="1280160"/>
           </a:xfrm>
           <a:prstGeom prst="rect">
             <a:avLst/>
@@ -6383,13 +6657,13 @@
           <a:lstStyle/>
           <a:p>
             <a:r>
-              <a:rPr sz="3400" b="1" i="0">
+              <a:rPr sz="3200" b="1" i="0">
                 <a:solidFill>
                   <a:srgbClr val="9D8DF1"/>
                 </a:solidFill>
                 <a:latin typeface="Inter"/>
               </a:rPr>
-              <a:t>Live demo</a:t>
+              <a:t>Let's look at the real thing</a:t>
             </a:r>
           </a:p>
         </p:txBody>
@@ -6402,8 +6676,8 @@
         </p:nvSpPr>
         <p:spPr>
           <a:xfrm>
-            <a:off x="658368" y="1965960"/>
-            <a:ext cx="1463040" cy="38100"/>
+            <a:off x="658368" y="2011680"/>
+            <a:ext cx="1371600" cy="38100"/>
           </a:xfrm>
           <a:prstGeom prst="rect">
             <a:avLst/>
@@ -6446,7 +6720,7 @@
         </p:nvSpPr>
         <p:spPr>
           <a:xfrm>
-            <a:off x="640080" y="2331720"/>
+            <a:off x="640080" y="2377440"/>
             <a:ext cx="10881360" cy="4023360"/>
           </a:xfrm>
           <a:prstGeom prst="rect">
@@ -6462,7 +6736,7 @@
           <a:p>
             <a:pPr>
               <a:spcAft>
-                <a:spcPts val="1200"/>
+                <a:spcPts val="1400"/>
               </a:spcAft>
             </a:pPr>
             <a:r>
@@ -6478,7 +6752,7 @@
           <a:p>
             <a:pPr>
               <a:spcAft>
-                <a:spcPts val="1200"/>
+                <a:spcPts val="1400"/>
               </a:spcAft>
             </a:pPr>
             <a:r>
@@ -6488,13 +6762,13 @@
                 </a:solidFill>
                 <a:latin typeface="Inter"/>
               </a:rPr>
-              <a:t>•  1.  Feed — scroll, tap art to play in place, react + comment</a:t>
+              <a:t>•  1.  Feed — scroll, tap the art to play, react and comment</a:t>
             </a:r>
           </a:p>
           <a:p>
             <a:pPr>
               <a:spcAft>
-                <a:spcPts val="1200"/>
+                <a:spcPts val="1400"/>
               </a:spcAft>
             </a:pPr>
             <a:r>
@@ -6504,13 +6778,13 @@
                 </a:solidFill>
                 <a:latin typeface="Inter"/>
               </a:rPr>
-              <a:t>•  2.  Share — 'share what you're hearing', post a real track</a:t>
+              <a:t>•  2.  Share — post the track I'm listening to right now</a:t>
             </a:r>
           </a:p>
           <a:p>
             <a:pPr>
               <a:spcAft>
-                <a:spcPts val="1200"/>
+                <a:spcPts val="1400"/>
               </a:spcAft>
             </a:pPr>
             <a:r>
@@ -6520,13 +6794,13 @@
                 </a:solidFill>
                 <a:latin typeface="Inter"/>
               </a:rPr>
-              <a:t>•  3.  Profile — taste community + % compatible (Andrea narrates)</a:t>
+              <a:t>•  3.  Profile — taste community + how compatible we are   (Andrea)</a:t>
             </a:r>
           </a:p>
           <a:p>
             <a:pPr>
               <a:spcAft>
-                <a:spcPts val="1200"/>
+                <a:spcPts val="1400"/>
               </a:spcAft>
             </a:pPr>
             <a:r>
@@ -6536,39 +6810,23 @@
                 </a:solidFill>
                 <a:latin typeface="Inter"/>
               </a:rPr>
-              <a:t>•  4.  Analytics — 7 tribes, distinctness, audio DNA (Jonah narrates)</a:t>
+              <a:t>•  4.  Analytics — the 7 communities and their 'audio DNA'   (Jonah)</a:t>
             </a:r>
           </a:p>
           <a:p>
             <a:pPr>
               <a:spcAft>
-                <a:spcPts val="1200"/>
+                <a:spcPts val="1400"/>
               </a:spcAft>
             </a:pPr>
             <a:r>
-              <a:rPr sz="2000" b="0" i="0">
-                <a:solidFill>
-                  <a:srgbClr val="EDEDF5"/>
-                </a:solidFill>
-                <a:latin typeface="Inter"/>
-              </a:rPr>
-              <a:t>•  5.  (Optional) Artist studio — a behind-the-scenes post</a:t>
-            </a:r>
-          </a:p>
-          <a:p>
-            <a:pPr>
-              <a:spcAft>
-                <a:spcPts val="1200"/>
-              </a:spcAft>
-            </a:pPr>
-            <a:r>
               <a:rPr sz="2000" b="1" i="0">
                 <a:solidFill>
                   <a:srgbClr val="F472B6"/>
                 </a:solidFill>
                 <a:latin typeface="Inter"/>
               </a:rPr>
-              <a:t>Warm the Render instance first. Screenshots on next slides are the fallback.</a:t>
+              <a:t>Warm the site up first. The next slides are screenshots, as a backup.</a:t>
             </a:r>
           </a:p>
         </p:txBody>
@@ -6649,7 +6907,7 @@
         </p:blipFill>
         <p:spPr>
           <a:xfrm>
-            <a:off x="4163379" y="1005840"/>
+            <a:off x="4148291" y="1005840"/>
             <a:ext cx="3864937" cy="5394960"/>
           </a:xfrm>
           <a:prstGeom prst="rect">
@@ -6733,7 +6991,7 @@
         </p:blipFill>
         <p:spPr>
           <a:xfrm>
-            <a:off x="4082399" y="1005840"/>
+            <a:off x="4067311" y="1005840"/>
             <a:ext cx="4026897" cy="5394960"/>
           </a:xfrm>
           <a:prstGeom prst="rect">
@@ -6796,7 +7054,7 @@
                 </a:solidFill>
                 <a:latin typeface="Inter"/>
               </a:rPr>
-              <a:t>Profile — taste community + % compatible</a:t>
+              <a:t>Profile — taste community + how compatible you are</a:t>
             </a:r>
           </a:p>
         </p:txBody>
@@ -6817,7 +7075,7 @@
         </p:blipFill>
         <p:spPr>
           <a:xfrm>
-            <a:off x="4185132" y="1005840"/>
+            <a:off x="4170045" y="1005840"/>
             <a:ext cx="3821430" cy="5394960"/>
           </a:xfrm>
           <a:prstGeom prst="rect">
@@ -6901,7 +7159,7 @@
         </p:blipFill>
         <p:spPr>
           <a:xfrm>
-            <a:off x="4207245" y="1005840"/>
+            <a:off x="4192158" y="1005840"/>
             <a:ext cx="3777204" cy="5394960"/>
           </a:xfrm>
           <a:prstGeom prst="rect">
@@ -6978,7 +7236,7 @@
         <p:spPr>
           <a:xfrm>
             <a:off x="640080" y="868680"/>
-            <a:ext cx="10881360" cy="1188720"/>
+            <a:ext cx="10881360" cy="1280160"/>
           </a:xfrm>
           <a:prstGeom prst="rect">
             <a:avLst/>
@@ -6992,14 +7250,13 @@
           <a:lstStyle/>
           <a:p>
             <a:r>
-              <a:rPr sz="3400" b="1" i="0">
+              <a:rPr sz="3200" b="1" i="0">
                 <a:solidFill>
                   <a:srgbClr val="9D8DF1"/>
                 </a:solidFill>
                 <a:latin typeface="Inter"/>
               </a:rPr>
-              <a:t>Your feed is what you perform.
-Your listening is who you are.</a:t>
+              <a:t>The idea</a:t>
             </a:r>
           </a:p>
         </p:txBody>
@@ -7012,8 +7269,8 @@
         </p:nvSpPr>
         <p:spPr>
           <a:xfrm>
-            <a:off x="658368" y="1965960"/>
-            <a:ext cx="1463040" cy="38100"/>
+            <a:off x="658368" y="2011680"/>
+            <a:ext cx="1371600" cy="38100"/>
           </a:xfrm>
           <a:prstGeom prst="rect">
             <a:avLst/>
@@ -7056,7 +7313,7 @@
         </p:nvSpPr>
         <p:spPr>
           <a:xfrm>
-            <a:off x="640080" y="2331720"/>
+            <a:off x="640080" y="2377440"/>
             <a:ext cx="10881360" cy="4023360"/>
           </a:xfrm>
           <a:prstGeom prst="rect">
@@ -7072,7 +7329,7 @@
           <a:p>
             <a:pPr>
               <a:spcAft>
-                <a:spcPts val="1200"/>
+                <a:spcPts val="1400"/>
               </a:spcAft>
             </a:pPr>
             <a:r>
@@ -7082,13 +7339,13 @@
                 </a:solidFill>
                 <a:latin typeface="Inter"/>
               </a:rPr>
-              <a:t>•  Social feeds show a curated performance.</a:t>
+              <a:t>•  On most apps, what you post is the highlight reel — a version of yourself.</a:t>
             </a:r>
           </a:p>
           <a:p>
             <a:pPr>
               <a:spcAft>
-                <a:spcPts val="1200"/>
+                <a:spcPts val="1400"/>
               </a:spcAft>
             </a:pPr>
             <a:r>
@@ -7098,39 +7355,39 @@
                 </a:solidFill>
                 <a:latin typeface="Inter"/>
               </a:rPr>
-              <a:t>•  Your listening history is honest — it's who you actually are musically.</a:t>
+              <a:t>•  What you listen to is more honest: it's just what you played.</a:t>
             </a:r>
           </a:p>
           <a:p>
             <a:pPr>
               <a:spcAft>
-                <a:spcPts val="1200"/>
+                <a:spcPts val="1400"/>
               </a:spcAft>
             </a:pPr>
             <a:r>
-              <a:rPr sz="2000" b="0" i="0">
-                <a:solidFill>
-                  <a:srgbClr val="EDEDF5"/>
-                </a:solidFill>
-                <a:latin typeface="Inter"/>
-              </a:rPr>
-              <a:t>•  Brink makes that the social object: share what you're really playing; friends react.</a:t>
+              <a:rPr sz="2000" b="1" i="0">
+                <a:solidFill>
+                  <a:srgbClr val="F472B6"/>
+                </a:solidFill>
+                <a:latin typeface="Inter"/>
+              </a:rPr>
+              <a:t>So we built the feed on that — and used it to find who listens like you.</a:t>
             </a:r>
           </a:p>
           <a:p>
             <a:pPr>
               <a:spcAft>
-                <a:spcPts val="1200"/>
+                <a:spcPts val="1400"/>
               </a:spcAft>
             </a:pPr>
             <a:r>
-              <a:rPr sz="2000" b="1" i="0">
-                <a:solidFill>
-                  <a:srgbClr val="F472B6"/>
-                </a:solidFill>
-                <a:latin typeface="Inter"/>
-              </a:rPr>
-              <a:t>Two questions drive everything: what do you listen to, and who listens like you?</a:t>
+              <a:rPr sz="2000" b="0" i="0">
+                <a:solidFill>
+                  <a:srgbClr val="EDEDF5"/>
+                </a:solidFill>
+                <a:latin typeface="Inter"/>
+              </a:rPr>
+              <a:t>•  Two questions run through the whole app: what do you listen to, and who matches you?</a:t>
             </a:r>
           </a:p>
         </p:txBody>
@@ -7190,7 +7447,7 @@
                 </a:solidFill>
                 <a:latin typeface="Inter"/>
               </a:rPr>
-              <a:t>Analytics — real model output: tribes &amp; audio DNA</a:t>
+              <a:t>Analytics — the model's real output: communities &amp; audio DNA</a:t>
             </a:r>
           </a:p>
         </p:txBody>
@@ -7211,7 +7468,7 @@
         </p:blipFill>
         <p:spPr>
           <a:xfrm>
-            <a:off x="4172711" y="1005840"/>
+            <a:off x="4157624" y="1005840"/>
             <a:ext cx="3846272" cy="5394960"/>
           </a:xfrm>
           <a:prstGeom prst="rect">
@@ -7288,7 +7545,7 @@
         <p:spPr>
           <a:xfrm>
             <a:off x="640080" y="868680"/>
-            <a:ext cx="10881360" cy="1188720"/>
+            <a:ext cx="10881360" cy="1280160"/>
           </a:xfrm>
           <a:prstGeom prst="rect">
             <a:avLst/>
@@ -7302,13 +7559,13 @@
           <a:lstStyle/>
           <a:p>
             <a:r>
-              <a:rPr sz="3400" b="1" i="0">
+              <a:rPr sz="3200" b="1" i="0">
                 <a:solidFill>
                   <a:srgbClr val="9D8DF1"/>
                 </a:solidFill>
                 <a:latin typeface="Inter"/>
               </a:rPr>
-              <a:t>What we learned</a:t>
+              <a:t>What we took away</a:t>
             </a:r>
           </a:p>
         </p:txBody>
@@ -7321,8 +7578,8 @@
         </p:nvSpPr>
         <p:spPr>
           <a:xfrm>
-            <a:off x="658368" y="1965960"/>
-            <a:ext cx="1463040" cy="38100"/>
+            <a:off x="658368" y="2011680"/>
+            <a:ext cx="1371600" cy="38100"/>
           </a:xfrm>
           <a:prstGeom prst="rect">
             <a:avLst/>
@@ -7365,7 +7622,7 @@
         </p:nvSpPr>
         <p:spPr>
           <a:xfrm>
-            <a:off x="640080" y="2331720"/>
+            <a:off x="640080" y="2377440"/>
             <a:ext cx="10881360" cy="4023360"/>
           </a:xfrm>
           <a:prstGeom prst="rect">
@@ -7381,7 +7638,7 @@
           <a:p>
             <a:pPr>
               <a:spcAft>
-                <a:spcPts val="1200"/>
+                <a:spcPts val="1400"/>
               </a:spcAft>
             </a:pPr>
             <a:r>
@@ -7391,13 +7648,13 @@
                 </a:solidFill>
                 <a:latin typeface="Inter"/>
               </a:rPr>
-              <a:t>Pivot early when you can't defend a choice  (Andrea)</a:t>
+              <a:t>The AI was only as good as the context and structure we gave it.  (Andrea)</a:t>
             </a:r>
           </a:p>
           <a:p>
             <a:pPr>
               <a:spcAft>
-                <a:spcPts val="1200"/>
+                <a:spcPts val="1400"/>
               </a:spcAft>
             </a:pPr>
             <a:r>
@@ -7407,13 +7664,13 @@
                 </a:solidFill>
                 <a:latin typeface="Inter"/>
               </a:rPr>
-              <a:t>Disclose limits, don't hide them — it made the analytics more credible  (Jonah)</a:t>
+              <a:t>Being honest about the model's limits made it more convincing, not less.  (Jonah)</a:t>
             </a:r>
           </a:p>
           <a:p>
             <a:pPr>
               <a:spcAft>
-                <a:spcPts val="1200"/>
+                <a:spcPts val="1400"/>
               </a:spcAft>
             </a:pPr>
             <a:r>
@@ -7423,7 +7680,7 @@
                 </a:solidFill>
                 <a:latin typeface="Inter"/>
               </a:rPr>
-              <a:t>One codebase + one theme let 3 people move fast without collisions  (Sebastian)</a:t>
+              <a:t>One codebase and one look let three people move without stepping on each other.  (Sebastian)</a:t>
             </a:r>
           </a:p>
         </p:txBody>
@@ -7521,7 +7778,7 @@
           <a:lstStyle/>
           <a:p>
             <a:r>
-              <a:rPr sz="5200" b="1" i="0">
+              <a:rPr sz="5000" b="1" i="0">
                 <a:solidFill>
                   <a:srgbClr val="EDEDF5"/>
                 </a:solidFill>
@@ -7540,7 +7797,7 @@
         </p:nvSpPr>
         <p:spPr>
           <a:xfrm>
-            <a:off x="822960" y="3794760"/>
+            <a:off x="822960" y="3749039"/>
             <a:ext cx="10515600" cy="914400"/>
           </a:xfrm>
           <a:prstGeom prst="rect">
@@ -7561,7 +7818,7 @@
                 </a:solidFill>
                 <a:latin typeface="Inter"/>
               </a:rPr>
-              <a:t>Thank you — questions?</a:t>
+              <a:t>Thanks — happy to take questions.</a:t>
             </a:r>
           </a:p>
         </p:txBody>
@@ -7574,7 +7831,7 @@
         </p:nvSpPr>
         <p:spPr>
           <a:xfrm>
-            <a:off x="822960" y="4754880"/>
+            <a:off x="822960" y="4709160"/>
             <a:ext cx="10515600" cy="1280160"/>
           </a:xfrm>
           <a:prstGeom prst="rect">
@@ -7669,7 +7926,7 @@
         <p:spPr>
           <a:xfrm>
             <a:off x="640080" y="868680"/>
-            <a:ext cx="10881360" cy="1188720"/>
+            <a:ext cx="6400800" cy="1280160"/>
           </a:xfrm>
           <a:prstGeom prst="rect">
             <a:avLst/>
@@ -7683,7 +7940,7 @@
           <a:lstStyle/>
           <a:p>
             <a:r>
-              <a:rPr sz="3400" b="1" i="0">
+              <a:rPr sz="3200" b="1" i="0">
                 <a:solidFill>
                   <a:srgbClr val="9D8DF1"/>
                 </a:solidFill>
@@ -7702,8 +7959,8 @@
         </p:nvSpPr>
         <p:spPr>
           <a:xfrm>
-            <a:off x="658368" y="1965960"/>
-            <a:ext cx="1463040" cy="38100"/>
+            <a:off x="658368" y="2011680"/>
+            <a:ext cx="1371600" cy="38100"/>
           </a:xfrm>
           <a:prstGeom prst="rect">
             <a:avLst/>
@@ -7746,8 +8003,8 @@
         </p:nvSpPr>
         <p:spPr>
           <a:xfrm>
-            <a:off x="640080" y="2331720"/>
-            <a:ext cx="10881360" cy="4023360"/>
+            <a:off x="640080" y="2377440"/>
+            <a:ext cx="5760720" cy="4023360"/>
           </a:xfrm>
           <a:prstGeom prst="rect">
             <a:avLst/>
@@ -7762,85 +8019,155 @@
           <a:p>
             <a:pPr>
               <a:spcAft>
-                <a:spcPts val="1200"/>
+                <a:spcPts val="1400"/>
               </a:spcAft>
             </a:pPr>
             <a:r>
-              <a:rPr sz="2000" b="1" i="0">
+              <a:rPr sz="1900" b="1" i="0">
                 <a:solidFill>
                   <a:srgbClr val="F472B6"/>
                 </a:solidFill>
                 <a:latin typeface="Inter"/>
               </a:rPr>
-              <a:t>Feed  —  songs that play in place, with reactions &amp; comments</a:t>
+              <a:t>Feed — songs that play right in the card, with reactions &amp; comments</a:t>
             </a:r>
           </a:p>
           <a:p>
             <a:pPr>
               <a:spcAft>
-                <a:spcPts val="1200"/>
+                <a:spcPts val="1400"/>
               </a:spcAft>
             </a:pPr>
             <a:r>
-              <a:rPr sz="2000" b="1" i="0">
+              <a:rPr sz="1900" b="1" i="0">
                 <a:solidFill>
                   <a:srgbClr val="F472B6"/>
                 </a:solidFill>
                 <a:latin typeface="Inter"/>
               </a:rPr>
-              <a:t>Taste communities  —  a cluster our model learns for every user</a:t>
+              <a:t>Taste communities — a group our model puts you in</a:t>
             </a:r>
           </a:p>
           <a:p>
             <a:pPr>
               <a:spcAft>
-                <a:spcPts val="1200"/>
+                <a:spcPts val="1400"/>
               </a:spcAft>
             </a:pPr>
             <a:r>
-              <a:rPr sz="2000" b="1" i="0">
+              <a:rPr sz="1900" b="1" i="0">
                 <a:solidFill>
                   <a:srgbClr val="F472B6"/>
                 </a:solidFill>
                 <a:latin typeface="Inter"/>
               </a:rPr>
-              <a:t>Compatibility  —  a score between any two people</a:t>
+              <a:t>Compatibility — how close two people's taste is</a:t>
             </a:r>
           </a:p>
           <a:p>
             <a:pPr>
               <a:spcAft>
-                <a:spcPts val="1200"/>
+                <a:spcPts val="1400"/>
               </a:spcAft>
             </a:pPr>
             <a:r>
-              <a:rPr sz="2000" b="1" i="0">
+              <a:rPr sz="1900" b="1" i="0">
                 <a:solidFill>
                   <a:srgbClr val="F472B6"/>
                 </a:solidFill>
                 <a:latin typeface="Inter"/>
               </a:rPr>
-              <a:t>Artist portal  —  behind-the-scenes posts to fans</a:t>
+              <a:t>Artist portal — behind-the-scenes posts to fans</a:t>
             </a:r>
           </a:p>
           <a:p>
             <a:pPr>
               <a:spcAft>
-                <a:spcPts val="1200"/>
+                <a:spcPts val="1400"/>
               </a:spcAft>
             </a:pPr>
             <a:r>
-              <a:rPr sz="2000" b="0" i="0">
+              <a:rPr sz="1900" b="0" i="0">
                 <a:solidFill>
                   <a:srgbClr val="EDEDF5"/>
                 </a:solidFill>
                 <a:latin typeface="Inter"/>
               </a:rPr>
-              <a:t>•  One live app, fully built — the full requirement list is delivered and traced.</a:t>
-            </a:r>
-          </a:p>
-        </p:txBody>
-      </p:sp>
+              <a:t>•  It's all one live app — everything we planned is built.</a:t>
+            </a:r>
+          </a:p>
+        </p:txBody>
+      </p:sp>
+      <p:sp>
+        <p:nvSpPr>
+          <p:cNvPr id="6" name="Rounded Rectangle 5"/>
+          <p:cNvSpPr/>
+          <p:nvPr/>
+        </p:nvSpPr>
+        <p:spPr>
+          <a:xfrm>
+            <a:off x="6720840" y="914400"/>
+            <a:ext cx="4846320" cy="5394960"/>
+          </a:xfrm>
+          <a:prstGeom prst="roundRect">
+            <a:avLst/>
+          </a:prstGeom>
+          <a:solidFill>
+            <a:srgbClr val="15151F"/>
+          </a:solidFill>
+          <a:ln w="12700">
+            <a:solidFill>
+              <a:srgbClr val="2E2E44"/>
+            </a:solidFill>
+          </a:ln>
+          <a:effectLst/>
+        </p:spPr>
+        <p:style>
+          <a:lnRef idx="1">
+            <a:schemeClr val="accent1"/>
+          </a:lnRef>
+          <a:fillRef idx="3">
+            <a:schemeClr val="accent1"/>
+          </a:fillRef>
+          <a:effectRef idx="2">
+            <a:schemeClr val="accent1"/>
+          </a:effectRef>
+          <a:fontRef idx="minor">
+            <a:schemeClr val="lt1"/>
+          </a:fontRef>
+        </p:style>
+        <p:txBody>
+          <a:bodyPr rtlCol="0" anchor="ctr"/>
+          <a:lstStyle/>
+          <a:p>
+            <a:pPr algn="ctr"/>
+          </a:p>
+        </p:txBody>
+      </p:sp>
+      <p:pic>
+        <p:nvPicPr>
+          <p:cNvPr id="7" name="Picture 6" descr="Feed-brink.png"/>
+          <p:cNvPicPr>
+            <a:picLocks noChangeAspect="1"/>
+          </p:cNvPicPr>
+          <p:nvPr/>
+        </p:nvPicPr>
+        <p:blipFill>
+          <a:blip r:embed="rId2"/>
+          <a:stretch>
+            <a:fillRect/>
+          </a:stretch>
+        </p:blipFill>
+        <p:spPr>
+          <a:xfrm>
+            <a:off x="7232930" y="1051560"/>
+            <a:ext cx="3822139" cy="5120640"/>
+          </a:xfrm>
+          <a:prstGeom prst="rect">
+            <a:avLst/>
+          </a:prstGeom>
+        </p:spPr>
+      </p:pic>
     </p:spTree>
   </p:cSld>
   <p:clrMapOvr>
@@ -7910,7 +8237,7 @@
         <p:spPr>
           <a:xfrm>
             <a:off x="640080" y="868680"/>
-            <a:ext cx="10881360" cy="914400"/>
+            <a:ext cx="10881360" cy="1280160"/>
           </a:xfrm>
           <a:prstGeom prst="rect">
             <a:avLst/>
@@ -7924,27 +8251,71 @@
           <a:lstStyle/>
           <a:p>
             <a:r>
-              <a:rPr sz="3000" b="1" i="0">
-                <a:solidFill>
-                  <a:srgbClr val="EDEDF5"/>
-                </a:solidFill>
-                <a:latin typeface="Inter"/>
-              </a:rPr>
-              <a:t>How it was built: process is a feature</a:t>
-            </a:r>
-          </a:p>
-        </p:txBody>
-      </p:sp>
-      <p:sp>
-        <p:nvSpPr>
-          <p:cNvPr id="4" name="TextBox 3"/>
+              <a:rPr sz="3200" b="1" i="0">
+                <a:solidFill>
+                  <a:srgbClr val="9D8DF1"/>
+                </a:solidFill>
+                <a:latin typeface="Inter"/>
+              </a:rPr>
+              <a:t>What we really set out to do</a:t>
+            </a:r>
+          </a:p>
+        </p:txBody>
+      </p:sp>
+      <p:sp>
+        <p:nvSpPr>
+          <p:cNvPr id="4" name="Rectangle 3"/>
+          <p:cNvSpPr/>
+          <p:nvPr/>
+        </p:nvSpPr>
+        <p:spPr>
+          <a:xfrm>
+            <a:off x="658368" y="2011680"/>
+            <a:ext cx="1371600" cy="38100"/>
+          </a:xfrm>
+          <a:prstGeom prst="rect">
+            <a:avLst/>
+          </a:prstGeom>
+          <a:solidFill>
+            <a:srgbClr val="9D8DF1"/>
+          </a:solidFill>
+          <a:ln>
+            <a:noFill/>
+          </a:ln>
+          <a:effectLst/>
+        </p:spPr>
+        <p:style>
+          <a:lnRef idx="1">
+            <a:schemeClr val="accent1"/>
+          </a:lnRef>
+          <a:fillRef idx="3">
+            <a:schemeClr val="accent1"/>
+          </a:fillRef>
+          <a:effectRef idx="2">
+            <a:schemeClr val="accent1"/>
+          </a:effectRef>
+          <a:fontRef idx="minor">
+            <a:schemeClr val="lt1"/>
+          </a:fontRef>
+        </p:style>
+        <p:txBody>
+          <a:bodyPr rtlCol="0" anchor="ctr"/>
+          <a:lstStyle/>
+          <a:p>
+            <a:pPr algn="ctr"/>
+          </a:p>
+        </p:txBody>
+      </p:sp>
+      <p:sp>
+        <p:nvSpPr>
+          <p:cNvPr id="5" name="TextBox 4"/>
           <p:cNvSpPr txBox="1"/>
           <p:nvPr/>
         </p:nvSpPr>
         <p:spPr>
           <a:xfrm>
             <a:off x="640080" y="2377440"/>
-            <a:ext cx="3566160" cy="1463040"/>
+            <a:ext cx="10881360" cy="4023360"/>
           </a:xfrm>
           <a:prstGeom prst="rect">
             <a:avLst/>
@@ -7957,228 +8328,83 @@
           </a:bodyPr>
           <a:lstStyle/>
           <a:p>
-            <a:pPr algn="ctr"/>
-            <a:r>
-              <a:rPr sz="6000" b="1" i="0">
-                <a:solidFill>
-                  <a:srgbClr val="9D8DF1"/>
-                </a:solidFill>
-                <a:latin typeface="Inter"/>
-              </a:rPr>
-              <a:t>16</a:t>
-            </a:r>
-          </a:p>
-        </p:txBody>
-      </p:sp>
-      <p:sp>
-        <p:nvSpPr>
-          <p:cNvPr id="5" name="TextBox 4"/>
-          <p:cNvSpPr txBox="1"/>
-          <p:nvPr/>
-        </p:nvSpPr>
-        <p:spPr>
-          <a:xfrm>
-            <a:off x="640080" y="3840480"/>
-            <a:ext cx="3566160" cy="914400"/>
-          </a:xfrm>
-          <a:prstGeom prst="rect">
-            <a:avLst/>
-          </a:prstGeom>
-          <a:noFill/>
-        </p:spPr>
-        <p:txBody>
-          <a:bodyPr wrap="square">
-            <a:spAutoFit/>
-          </a:bodyPr>
-          <a:lstStyle/>
-          <a:p>
-            <a:pPr algn="ctr"/>
-            <a:r>
-              <a:rPr sz="1800" b="0" i="0">
-                <a:solidFill>
-                  <a:srgbClr val="8A8AA3"/>
-                </a:solidFill>
-                <a:latin typeface="Inter"/>
-              </a:rPr>
-              <a:t>Architecture
-Decision Records</a:t>
-            </a:r>
-          </a:p>
-        </p:txBody>
-      </p:sp>
-      <p:sp>
-        <p:nvSpPr>
-          <p:cNvPr id="6" name="TextBox 5"/>
-          <p:cNvSpPr txBox="1"/>
-          <p:nvPr/>
-        </p:nvSpPr>
-        <p:spPr>
-          <a:xfrm>
-            <a:off x="4297680" y="2377440"/>
-            <a:ext cx="3566160" cy="1463040"/>
-          </a:xfrm>
-          <a:prstGeom prst="rect">
-            <a:avLst/>
-          </a:prstGeom>
-          <a:noFill/>
-        </p:spPr>
-        <p:txBody>
-          <a:bodyPr wrap="square">
-            <a:spAutoFit/>
-          </a:bodyPr>
-          <a:lstStyle/>
-          <a:p>
-            <a:pPr algn="ctr"/>
-            <a:r>
-              <a:rPr sz="6000" b="1" i="0">
+            <a:pPr>
+              <a:spcAft>
+                <a:spcPts val="1400"/>
+              </a:spcAft>
+            </a:pPr>
+            <a:r>
+              <a:rPr sz="2000" b="0" i="0">
+                <a:solidFill>
+                  <a:srgbClr val="EDEDF5"/>
+                </a:solidFill>
+                <a:latin typeface="Inter"/>
+              </a:rPr>
+              <a:t>•  A big goal was to see how far we could get by leaning on AI coding agents.</a:t>
+            </a:r>
+          </a:p>
+          <a:p>
+            <a:pPr>
+              <a:spcAft>
+                <a:spcPts val="1400"/>
+              </a:spcAft>
+            </a:pPr>
+            <a:r>
+              <a:rPr sz="2000" b="0" i="0">
+                <a:solidFill>
+                  <a:srgbClr val="EDEDF5"/>
+                </a:solidFill>
+                <a:latin typeface="Inter"/>
+              </a:rPr>
+              <a:t>•  We learned fast: AI is only as good as the context you give it.</a:t>
+            </a:r>
+          </a:p>
+          <a:p>
+            <a:pPr>
+              <a:spcAft>
+                <a:spcPts val="1400"/>
+              </a:spcAft>
+            </a:pPr>
+            <a:r>
+              <a:rPr sz="2000" b="0" i="0">
+                <a:solidFill>
+                  <a:srgbClr val="EDEDF5"/>
+                </a:solidFill>
+                <a:latin typeface="Inter"/>
+              </a:rPr>
+              <a:t>•  So the job was two things — give the agents rich context, and be exact about what to build.</a:t>
+            </a:r>
+          </a:p>
+          <a:p>
+            <a:pPr>
+              <a:spcAft>
+                <a:spcPts val="1400"/>
+              </a:spcAft>
+            </a:pPr>
+            <a:r>
+              <a:rPr sz="2000" b="1" i="0">
                 <a:solidFill>
                   <a:srgbClr val="F472B6"/>
                 </a:solidFill>
                 <a:latin typeface="Inter"/>
               </a:rPr>
-              <a:t>82</a:t>
-            </a:r>
-          </a:p>
-        </p:txBody>
-      </p:sp>
-      <p:sp>
-        <p:nvSpPr>
-          <p:cNvPr id="7" name="TextBox 6"/>
-          <p:cNvSpPr txBox="1"/>
-          <p:nvPr/>
-        </p:nvSpPr>
-        <p:spPr>
-          <a:xfrm>
-            <a:off x="4297680" y="3840480"/>
-            <a:ext cx="3566160" cy="914400"/>
-          </a:xfrm>
-          <a:prstGeom prst="rect">
-            <a:avLst/>
-          </a:prstGeom>
-          <a:noFill/>
-        </p:spPr>
-        <p:txBody>
-          <a:bodyPr wrap="square">
-            <a:spAutoFit/>
-          </a:bodyPr>
-          <a:lstStyle/>
-          <a:p>
-            <a:pPr algn="ctr"/>
-            <a:r>
-              <a:rPr sz="1800" b="0" i="0">
-                <a:solidFill>
-                  <a:srgbClr val="8A8AA3"/>
-                </a:solidFill>
-                <a:latin typeface="Inter"/>
-              </a:rPr>
-              <a:t>tickets, each
-tied to a requirement</a:t>
-            </a:r>
-          </a:p>
-        </p:txBody>
-      </p:sp>
-      <p:sp>
-        <p:nvSpPr>
-          <p:cNvPr id="8" name="TextBox 7"/>
-          <p:cNvSpPr txBox="1"/>
-          <p:nvPr/>
-        </p:nvSpPr>
-        <p:spPr>
-          <a:xfrm>
-            <a:off x="7955280" y="2377440"/>
-            <a:ext cx="3566160" cy="1463040"/>
-          </a:xfrm>
-          <a:prstGeom prst="rect">
-            <a:avLst/>
-          </a:prstGeom>
-          <a:noFill/>
-        </p:spPr>
-        <p:txBody>
-          <a:bodyPr wrap="square">
-            <a:spAutoFit/>
-          </a:bodyPr>
-          <a:lstStyle/>
-          <a:p>
-            <a:pPr algn="ctr"/>
-            <a:r>
-              <a:rPr sz="6000" b="1" i="0">
-                <a:solidFill>
-                  <a:srgbClr val="9D8DF1"/>
-                </a:solidFill>
-                <a:latin typeface="Inter"/>
-              </a:rPr>
-              <a:t>~320</a:t>
-            </a:r>
-          </a:p>
-        </p:txBody>
-      </p:sp>
-      <p:sp>
-        <p:nvSpPr>
-          <p:cNvPr id="9" name="TextBox 8"/>
-          <p:cNvSpPr txBox="1"/>
-          <p:nvPr/>
-        </p:nvSpPr>
-        <p:spPr>
-          <a:xfrm>
-            <a:off x="7955280" y="3840480"/>
-            <a:ext cx="3566160" cy="914400"/>
-          </a:xfrm>
-          <a:prstGeom prst="rect">
-            <a:avLst/>
-          </a:prstGeom>
-          <a:noFill/>
-        </p:spPr>
-        <p:txBody>
-          <a:bodyPr wrap="square">
-            <a:spAutoFit/>
-          </a:bodyPr>
-          <a:lstStyle/>
-          <a:p>
-            <a:pPr algn="ctr"/>
-            <a:r>
-              <a:rPr sz="1800" b="0" i="0">
-                <a:solidFill>
-                  <a:srgbClr val="8A8AA3"/>
-                </a:solidFill>
-                <a:latin typeface="Inter"/>
-              </a:rPr>
-              <a:t>automated
-tests</a:t>
-            </a:r>
-          </a:p>
-        </p:txBody>
-      </p:sp>
-      <p:sp>
-        <p:nvSpPr>
-          <p:cNvPr id="10" name="TextBox 9"/>
-          <p:cNvSpPr txBox="1"/>
-          <p:nvPr/>
-        </p:nvSpPr>
-        <p:spPr>
-          <a:xfrm>
-            <a:off x="640080" y="5212080"/>
-            <a:ext cx="10881360" cy="914400"/>
-          </a:xfrm>
-          <a:prstGeom prst="rect">
-            <a:avLst/>
-          </a:prstGeom>
-          <a:noFill/>
-        </p:spPr>
-        <p:txBody>
-          <a:bodyPr wrap="square">
-            <a:spAutoFit/>
-          </a:bodyPr>
-          <a:lstStyle/>
-          <a:p>
-            <a:pPr algn="ctr"/>
-            <a:r>
-              <a:rPr sz="2000" b="0" i="1">
+              <a:t>Our first couple of weeks were planning, not code:  ADRs, tickets, and project governance.</a:t>
+            </a:r>
+          </a:p>
+          <a:p>
+            <a:pPr>
+              <a:spcAft>
+                <a:spcPts val="1400"/>
+              </a:spcAft>
+            </a:pPr>
+            <a:r>
+              <a:rPr sz="2000" b="0" i="0">
                 <a:solidFill>
                   <a:srgbClr val="EDEDF5"/>
                 </a:solidFill>
                 <a:latin typeface="Inter"/>
               </a:rPr>
-              <a:t>A 3-person team, built to be owned and defended.</a:t>
+              <a:t>•  That groundwork is what let everything after it move quickly.</a:t>
             </a:r>
           </a:p>
         </p:txBody>
@@ -8252,7 +8478,7 @@
         <p:spPr>
           <a:xfrm>
             <a:off x="640080" y="868680"/>
-            <a:ext cx="10881360" cy="1188720"/>
+            <a:ext cx="10881360" cy="1280160"/>
           </a:xfrm>
           <a:prstGeom prst="rect">
             <a:avLst/>
@@ -8266,13 +8492,13 @@
           <a:lstStyle/>
           <a:p>
             <a:r>
-              <a:rPr sz="3400" b="1" i="0">
+              <a:rPr sz="3200" b="1" i="0">
                 <a:solidFill>
                   <a:srgbClr val="9D8DF1"/>
                 </a:solidFill>
                 <a:latin typeface="Inter"/>
               </a:rPr>
-              <a:t>Decide → Scope → Enforce</a:t>
+              <a:t>The scaffolding that let AI build</a:t>
             </a:r>
           </a:p>
         </p:txBody>
@@ -8285,8 +8511,8 @@
         </p:nvSpPr>
         <p:spPr>
           <a:xfrm>
-            <a:off x="658368" y="1965960"/>
-            <a:ext cx="1463040" cy="38100"/>
+            <a:off x="658368" y="2011680"/>
+            <a:ext cx="1371600" cy="38100"/>
           </a:xfrm>
           <a:prstGeom prst="rect">
             <a:avLst/>
@@ -8323,103 +8549,321 @@
       </p:sp>
       <p:sp>
         <p:nvSpPr>
-          <p:cNvPr id="5" name="TextBox 4"/>
-          <p:cNvSpPr txBox="1"/>
+          <p:cNvPr id="5" name="Rounded Rectangle 4"/>
+          <p:cNvSpPr/>
           <p:nvPr/>
         </p:nvSpPr>
         <p:spPr>
           <a:xfrm>
-            <a:off x="640080" y="2331720"/>
-            <a:ext cx="10881360" cy="4023360"/>
-          </a:xfrm>
-          <a:prstGeom prst="rect">
-            <a:avLst/>
-          </a:prstGeom>
-          <a:noFill/>
-        </p:spPr>
-        <p:txBody>
-          <a:bodyPr wrap="square">
-            <a:spAutoFit/>
-          </a:bodyPr>
-          <a:lstStyle/>
+            <a:off x="640080" y="2468880"/>
+            <a:ext cx="3429000" cy="3200400"/>
+          </a:xfrm>
+          <a:prstGeom prst="roundRect">
+            <a:avLst/>
+          </a:prstGeom>
+          <a:solidFill>
+            <a:srgbClr val="15151F"/>
+          </a:solidFill>
+          <a:ln w="19050">
+            <a:solidFill>
+              <a:srgbClr val="9D8DF1"/>
+            </a:solidFill>
+          </a:ln>
+          <a:effectLst/>
+        </p:spPr>
+        <p:style>
+          <a:lnRef idx="1">
+            <a:schemeClr val="accent1"/>
+          </a:lnRef>
+          <a:fillRef idx="3">
+            <a:schemeClr val="accent1"/>
+          </a:fillRef>
+          <a:effectRef idx="2">
+            <a:schemeClr val="accent1"/>
+          </a:effectRef>
+          <a:fontRef idx="minor">
+            <a:schemeClr val="lt1"/>
+          </a:fontRef>
+        </p:style>
+        <p:txBody>
+          <a:bodyPr rtlCol="0" anchor="ctr" wrap="square" lIns="228600" rIns="182880" tIns="228600"/>
+          <a:lstStyle/>
+          <a:p>
+            <a:pPr algn="ctr">
+              <a:spcAft>
+                <a:spcPts val="1000"/>
+              </a:spcAft>
+            </a:pPr>
+            <a:r>
+              <a:rPr sz="2000" b="1" i="0">
+                <a:solidFill>
+                  <a:srgbClr val="9D8DF1"/>
+                </a:solidFill>
+                <a:latin typeface="Inter"/>
+              </a:rPr>
+              <a:t>ADRs</a:t>
+            </a:r>
+          </a:p>
           <a:p>
             <a:pPr>
               <a:spcAft>
-                <a:spcPts val="1200"/>
+                <a:spcPts val="800"/>
               </a:spcAft>
             </a:pPr>
             <a:r>
-              <a:rPr sz="2000" b="1" i="0">
-                <a:solidFill>
-                  <a:srgbClr val="F472B6"/>
-                </a:solidFill>
-                <a:latin typeface="Inter"/>
-              </a:rPr>
-              <a:t>Decide  —  every choice is an append-only ADR; we supersede, never edit</a:t>
+              <a:rPr sz="1500" b="0" i="0">
+                <a:solidFill>
+                  <a:srgbClr val="EDEDF5"/>
+                </a:solidFill>
+                <a:latin typeface="Inter"/>
+              </a:rPr>
+              <a:t>Every real decision, written down with the reasoning.</a:t>
             </a:r>
           </a:p>
           <a:p>
             <a:pPr>
               <a:spcAft>
-                <a:spcPts val="1200"/>
+                <a:spcPts val="800"/>
               </a:spcAft>
             </a:pPr>
             <a:r>
-              <a:rPr sz="2000" b="1" i="0">
-                <a:solidFill>
-                  <a:srgbClr val="F472B6"/>
-                </a:solidFill>
-                <a:latin typeface="Inter"/>
-              </a:rPr>
-              <a:t>Scope  —  one ticket = one PR, traced to a requirement; no scope creep</a:t>
+              <a:rPr sz="1500" b="0" i="0">
+                <a:solidFill>
+                  <a:srgbClr val="EDEDF5"/>
+                </a:solidFill>
+                <a:latin typeface="Inter"/>
+              </a:rPr>
+              <a:t>So an agent — or a teammate — knows why things are the way they are.</a:t>
             </a:r>
           </a:p>
           <a:p>
             <a:pPr>
               <a:spcAft>
-                <a:spcPts val="1200"/>
+                <a:spcPts val="800"/>
               </a:spcAft>
             </a:pPr>
             <a:r>
+              <a:rPr sz="1500" b="0" i="0">
+                <a:solidFill>
+                  <a:srgbClr val="EDEDF5"/>
+                </a:solidFill>
+                <a:latin typeface="Inter"/>
+              </a:rPr>
+              <a:t>Append-only: we supersede, never quietly edit.</a:t>
+            </a:r>
+          </a:p>
+        </p:txBody>
+      </p:sp>
+      <p:sp>
+        <p:nvSpPr>
+          <p:cNvPr id="6" name="Rounded Rectangle 5"/>
+          <p:cNvSpPr/>
+          <p:nvPr/>
+        </p:nvSpPr>
+        <p:spPr>
+          <a:xfrm>
+            <a:off x="4343400" y="2468880"/>
+            <a:ext cx="3429000" cy="3200400"/>
+          </a:xfrm>
+          <a:prstGeom prst="roundRect">
+            <a:avLst/>
+          </a:prstGeom>
+          <a:solidFill>
+            <a:srgbClr val="15151F"/>
+          </a:solidFill>
+          <a:ln w="19050">
+            <a:solidFill>
+              <a:srgbClr val="F472B6"/>
+            </a:solidFill>
+          </a:ln>
+          <a:effectLst/>
+        </p:spPr>
+        <p:style>
+          <a:lnRef idx="1">
+            <a:schemeClr val="accent1"/>
+          </a:lnRef>
+          <a:fillRef idx="3">
+            <a:schemeClr val="accent1"/>
+          </a:fillRef>
+          <a:effectRef idx="2">
+            <a:schemeClr val="accent1"/>
+          </a:effectRef>
+          <a:fontRef idx="minor">
+            <a:schemeClr val="lt1"/>
+          </a:fontRef>
+        </p:style>
+        <p:txBody>
+          <a:bodyPr rtlCol="0" anchor="ctr" wrap="square" lIns="228600" rIns="182880" tIns="228600"/>
+          <a:lstStyle/>
+          <a:p>
+            <a:pPr algn="ctr">
+              <a:spcAft>
+                <a:spcPts val="1000"/>
+              </a:spcAft>
+            </a:pPr>
+            <a:r>
               <a:rPr sz="2000" b="1" i="0">
                 <a:solidFill>
                   <a:srgbClr val="F472B6"/>
                 </a:solidFill>
                 <a:latin typeface="Inter"/>
               </a:rPr>
-              <a:t>Enforce  —  CI runs tests + a secret scan on every PR</a:t>
+              <a:t>Tickets</a:t>
             </a:r>
           </a:p>
           <a:p>
             <a:pPr>
               <a:spcAft>
-                <a:spcPts val="1200"/>
+                <a:spcPts val="800"/>
               </a:spcAft>
             </a:pPr>
             <a:r>
-              <a:rPr sz="2000" b="1" i="0">
-                <a:solidFill>
-                  <a:srgbClr val="F472B6"/>
-                </a:solidFill>
-                <a:latin typeface="Inter"/>
-              </a:rPr>
-              <a:t>+ a custom docs-sync gate: change code but not its docs and the build fails</a:t>
+              <a:rPr sz="1500" b="0" i="0">
+                <a:solidFill>
+                  <a:srgbClr val="EDEDF5"/>
+                </a:solidFill>
+                <a:latin typeface="Inter"/>
+              </a:rPr>
+              <a:t>One clear piece of work at a time.</a:t>
             </a:r>
           </a:p>
           <a:p>
             <a:pPr>
               <a:spcAft>
-                <a:spcPts val="1200"/>
+                <a:spcPts val="800"/>
               </a:spcAft>
             </a:pPr>
             <a:r>
-              <a:rPr sz="2000" b="0" i="0">
+              <a:rPr sz="1500" b="0" i="0">
                 <a:solidFill>
                   <a:srgbClr val="EDEDF5"/>
                 </a:solidFill>
                 <a:latin typeface="Inter"/>
               </a:rPr>
-              <a:t>•  You literally cannot merge stale documentation.</a:t>
+              <a:t>The agent builds exactly that — nothing more.</a:t>
+            </a:r>
+          </a:p>
+          <a:p>
+            <a:pPr>
+              <a:spcAft>
+                <a:spcPts val="800"/>
+              </a:spcAft>
+            </a:pPr>
+            <a:r>
+              <a:rPr sz="1500" b="0" i="0">
+                <a:solidFill>
+                  <a:srgbClr val="EDEDF5"/>
+                </a:solidFill>
+                <a:latin typeface="Inter"/>
+              </a:rPr>
+              <a:t>Each one traces back to a requirement.</a:t>
+            </a:r>
+          </a:p>
+        </p:txBody>
+      </p:sp>
+      <p:sp>
+        <p:nvSpPr>
+          <p:cNvPr id="7" name="Rounded Rectangle 6"/>
+          <p:cNvSpPr/>
+          <p:nvPr/>
+        </p:nvSpPr>
+        <p:spPr>
+          <a:xfrm>
+            <a:off x="8046720" y="2468880"/>
+            <a:ext cx="3429000" cy="3200400"/>
+          </a:xfrm>
+          <a:prstGeom prst="roundRect">
+            <a:avLst/>
+          </a:prstGeom>
+          <a:solidFill>
+            <a:srgbClr val="15151F"/>
+          </a:solidFill>
+          <a:ln w="19050">
+            <a:solidFill>
+              <a:srgbClr val="5EEAD4"/>
+            </a:solidFill>
+          </a:ln>
+          <a:effectLst/>
+        </p:spPr>
+        <p:style>
+          <a:lnRef idx="1">
+            <a:schemeClr val="accent1"/>
+          </a:lnRef>
+          <a:fillRef idx="3">
+            <a:schemeClr val="accent1"/>
+          </a:fillRef>
+          <a:effectRef idx="2">
+            <a:schemeClr val="accent1"/>
+          </a:effectRef>
+          <a:fontRef idx="minor">
+            <a:schemeClr val="lt1"/>
+          </a:fontRef>
+        </p:style>
+        <p:txBody>
+          <a:bodyPr rtlCol="0" anchor="ctr" wrap="square" lIns="228600" rIns="182880" tIns="228600"/>
+          <a:lstStyle/>
+          <a:p>
+            <a:pPr algn="ctr">
+              <a:spcAft>
+                <a:spcPts val="1000"/>
+              </a:spcAft>
+            </a:pPr>
+            <a:r>
+              <a:rPr sz="2000" b="1" i="0">
+                <a:solidFill>
+                  <a:srgbClr val="5EEAD4"/>
+                </a:solidFill>
+                <a:latin typeface="Inter"/>
+              </a:rPr>
+              <a:t>Governance</a:t>
+            </a:r>
+          </a:p>
+          <a:p>
+            <a:pPr>
+              <a:spcAft>
+                <a:spcPts val="800"/>
+              </a:spcAft>
+            </a:pPr>
+            <a:r>
+              <a:rPr sz="1500" b="0" i="0">
+                <a:solidFill>
+                  <a:srgbClr val="EDEDF5"/>
+                </a:solidFill>
+                <a:latin typeface="Inter"/>
+              </a:rPr>
+              <a:t>Guardrails around every change: one PR at a time.</a:t>
+            </a:r>
+          </a:p>
+          <a:p>
+            <a:pPr>
+              <a:spcAft>
+                <a:spcPts val="800"/>
+              </a:spcAft>
+            </a:pPr>
+            <a:r>
+              <a:rPr sz="1500" b="0" i="0">
+                <a:solidFill>
+                  <a:srgbClr val="EDEDF5"/>
+                </a:solidFill>
+                <a:latin typeface="Inter"/>
+              </a:rPr>
+              <a:t>CI runs tests + a secret scan automatically.</a:t>
+            </a:r>
+          </a:p>
+          <a:p>
+            <a:pPr>
+              <a:spcAft>
+                <a:spcPts val="800"/>
+              </a:spcAft>
+            </a:pPr>
+            <a:r>
+              <a:rPr sz="1500" b="0" i="0">
+                <a:solidFill>
+                  <a:srgbClr val="EDEDF5"/>
+                </a:solidFill>
+                <a:latin typeface="Inter"/>
+              </a:rPr>
+              <a:t>A check fails if you change code but not its docs.</a:t>
             </a:r>
           </a:p>
         </p:txBody>
@@ -8493,7 +8937,7 @@
         <p:spPr>
           <a:xfrm>
             <a:off x="640080" y="868680"/>
-            <a:ext cx="10881360" cy="1188720"/>
+            <a:ext cx="10881360" cy="1280160"/>
           </a:xfrm>
           <a:prstGeom prst="rect">
             <a:avLst/>
@@ -8507,13 +8951,13 @@
           <a:lstStyle/>
           <a:p>
             <a:r>
-              <a:rPr sz="3400" b="1" i="0">
+              <a:rPr sz="3200" b="1" i="0">
                 <a:solidFill>
                   <a:srgbClr val="9D8DF1"/>
                 </a:solidFill>
                 <a:latin typeface="Inter"/>
               </a:rPr>
-              <a:t>Two pivots, one principle</a:t>
+              <a:t>Two times we changed our minds</a:t>
             </a:r>
           </a:p>
         </p:txBody>
@@ -8526,8 +8970,8 @@
         </p:nvSpPr>
         <p:spPr>
           <a:xfrm>
-            <a:off x="658368" y="1965960"/>
-            <a:ext cx="1463040" cy="38100"/>
+            <a:off x="658368" y="2011680"/>
+            <a:ext cx="1371600" cy="38100"/>
           </a:xfrm>
           <a:prstGeom prst="rect">
             <a:avLst/>
@@ -8570,7 +9014,7 @@
         </p:nvSpPr>
         <p:spPr>
           <a:xfrm>
-            <a:off x="640080" y="2331720"/>
+            <a:off x="640080" y="2377440"/>
             <a:ext cx="10881360" cy="4023360"/>
           </a:xfrm>
           <a:prstGeom prst="rect">
@@ -8586,7 +9030,7 @@
           <a:p>
             <a:pPr>
               <a:spcAft>
-                <a:spcPts val="1200"/>
+                <a:spcPts val="1400"/>
               </a:spcAft>
             </a:pPr>
             <a:r>
@@ -8596,13 +9040,13 @@
                 </a:solidFill>
                 <a:latin typeface="Inter"/>
               </a:rPr>
-              <a:t>•  TypeScript / Vercel / Prisma  →  FastAPI / Render   (ADR-0010)</a:t>
+              <a:t>•  Backend:  TypeScript / Vercel  →  Python / FastAPI   (ADR-0010)</a:t>
             </a:r>
           </a:p>
           <a:p>
             <a:pPr>
               <a:spcAft>
-                <a:spcPts val="1200"/>
+                <a:spcPts val="1400"/>
               </a:spcAft>
             </a:pPr>
             <a:r>
@@ -8612,13 +9056,13 @@
                 </a:solidFill>
                 <a:latin typeface="Inter"/>
               </a:rPr>
-              <a:t>•  React / Vite SPA  →  server-rendered Jinja pages   (ADR-0013)</a:t>
+              <a:t>•  Frontend:  React app  →  simpler server-rendered pages   (ADR-0013)</a:t>
             </a:r>
           </a:p>
           <a:p>
             <a:pPr>
               <a:spcAft>
-                <a:spcPts val="1200"/>
+                <a:spcPts val="1400"/>
               </a:spcAft>
             </a:pPr>
             <a:r>
@@ -8628,13 +9072,13 @@
                 </a:solidFill>
                 <a:latin typeface="Inter"/>
               </a:rPr>
-              <a:t>Why: security-critical code in a language not all of us could review is a liability</a:t>
+              <a:t>Why both times: the security-sensitive parts were in a stack we couldn't all read.</a:t>
             </a:r>
           </a:p>
           <a:p>
             <a:pPr>
               <a:spcAft>
-                <a:spcPts val="1200"/>
+                <a:spcPts val="1400"/>
               </a:spcAft>
             </a:pPr>
             <a:r>
@@ -8644,7 +9088,7 @@
                 </a:solidFill>
                 <a:latin typeface="Inter"/>
               </a:rPr>
-              <a:t>•  End state: one Python codebase every one of us can read, review, and defend.</a:t>
+              <a:t>•  Now it's one Python codebase all three of us can actually read and defend.</a:t>
             </a:r>
           </a:p>
         </p:txBody>
@@ -8683,7 +9127,7 @@
         </p:nvSpPr>
         <p:spPr>
           <a:xfrm>
-            <a:off x="640080" y="457200"/>
+            <a:off x="640080" y="411480"/>
             <a:ext cx="10881360" cy="365760"/>
           </a:xfrm>
           <a:prstGeom prst="rect">
@@ -8717,8 +9161,8 @@
         </p:nvSpPr>
         <p:spPr>
           <a:xfrm>
-            <a:off x="640080" y="868680"/>
-            <a:ext cx="10881360" cy="1188720"/>
+            <a:off x="640080" y="777240"/>
+            <a:ext cx="10881360" cy="640080"/>
           </a:xfrm>
           <a:prstGeom prst="rect">
             <a:avLst/>
@@ -8732,36 +9176,38 @@
           <a:lstStyle/>
           <a:p>
             <a:r>
-              <a:rPr sz="3400" b="1" i="0">
+              <a:rPr sz="3000" b="1" i="0">
                 <a:solidFill>
                   <a:srgbClr val="9D8DF1"/>
                 </a:solidFill>
                 <a:latin typeface="Inter"/>
               </a:rPr>
-              <a:t>Architecture at a glance</a:t>
-            </a:r>
-          </a:p>
-        </p:txBody>
-      </p:sp>
-      <p:sp>
-        <p:nvSpPr>
-          <p:cNvPr id="4" name="Rectangle 3"/>
+              <a:t>How it fits together</a:t>
+            </a:r>
+          </a:p>
+        </p:txBody>
+      </p:sp>
+      <p:sp>
+        <p:nvSpPr>
+          <p:cNvPr id="4" name="Rounded Rectangle 3"/>
           <p:cNvSpPr/>
           <p:nvPr/>
         </p:nvSpPr>
         <p:spPr>
           <a:xfrm>
-            <a:off x="658368" y="1965960"/>
-            <a:ext cx="1463040" cy="38100"/>
-          </a:xfrm>
-          <a:prstGeom prst="rect">
+            <a:off x="640080" y="1737360"/>
+            <a:ext cx="2468880" cy="914400"/>
+          </a:xfrm>
+          <a:prstGeom prst="roundRect">
             <a:avLst/>
           </a:prstGeom>
           <a:solidFill>
-            <a:srgbClr val="9D8DF1"/>
+            <a:srgbClr val="15151F"/>
           </a:solidFill>
-          <a:ln>
-            <a:noFill/>
+          <a:ln w="19050">
+            <a:solidFill>
+              <a:srgbClr val="F472B6"/>
+            </a:solidFill>
           </a:ln>
           <a:effectLst/>
         </p:spPr>
@@ -8780,23 +9226,759 @@
           </a:fontRef>
         </p:style>
         <p:txBody>
-          <a:bodyPr rtlCol="0" anchor="ctr"/>
+          <a:bodyPr rtlCol="0" anchor="ctr" wrap="square" lIns="54864" rIns="54864" tIns="27432" bIns="27432"/>
           <a:lstStyle/>
           <a:p>
             <a:pPr algn="ctr"/>
-          </a:p>
-        </p:txBody>
-      </p:sp>
-      <p:sp>
-        <p:nvSpPr>
-          <p:cNvPr id="5" name="TextBox 4"/>
+            <a:r>
+              <a:rPr sz="1300" b="1" i="0">
+                <a:solidFill>
+                  <a:srgbClr val="EDEDF5"/>
+                </a:solidFill>
+                <a:latin typeface="Inter"/>
+              </a:rPr>
+              <a:t>Spotify</a:t>
+            </a:r>
+          </a:p>
+          <a:p>
+            <a:pPr algn="ctr"/>
+            <a:r>
+              <a:rPr sz="1000" b="0" i="0">
+                <a:solidFill>
+                  <a:srgbClr val="8A8AA3"/>
+                </a:solidFill>
+                <a:latin typeface="Inter"/>
+              </a:rPr>
+              <a:t>logins · listening · catalog</a:t>
+            </a:r>
+          </a:p>
+        </p:txBody>
+      </p:sp>
+      <p:sp>
+        <p:nvSpPr>
+          <p:cNvPr id="5" name="Rounded Rectangle 4"/>
+          <p:cNvSpPr/>
+          <p:nvPr/>
+        </p:nvSpPr>
+        <p:spPr>
+          <a:xfrm>
+            <a:off x="4709160" y="1737360"/>
+            <a:ext cx="2743200" cy="914400"/>
+          </a:xfrm>
+          <a:prstGeom prst="roundRect">
+            <a:avLst/>
+          </a:prstGeom>
+          <a:solidFill>
+            <a:srgbClr val="15151F"/>
+          </a:solidFill>
+          <a:ln w="19050">
+            <a:solidFill>
+              <a:srgbClr val="9D8DF1"/>
+            </a:solidFill>
+          </a:ln>
+          <a:effectLst/>
+        </p:spPr>
+        <p:style>
+          <a:lnRef idx="1">
+            <a:schemeClr val="accent1"/>
+          </a:lnRef>
+          <a:fillRef idx="3">
+            <a:schemeClr val="accent1"/>
+          </a:fillRef>
+          <a:effectRef idx="2">
+            <a:schemeClr val="accent1"/>
+          </a:effectRef>
+          <a:fontRef idx="minor">
+            <a:schemeClr val="lt1"/>
+          </a:fontRef>
+        </p:style>
+        <p:txBody>
+          <a:bodyPr rtlCol="0" anchor="ctr" wrap="square" lIns="54864" rIns="54864" tIns="27432" bIns="27432"/>
+          <a:lstStyle/>
+          <a:p>
+            <a:pPr algn="ctr"/>
+            <a:r>
+              <a:rPr sz="1300" b="1" i="0">
+                <a:solidFill>
+                  <a:srgbClr val="EDEDF5"/>
+                </a:solidFill>
+                <a:latin typeface="Inter"/>
+              </a:rPr>
+              <a:t>Your browser</a:t>
+            </a:r>
+          </a:p>
+          <a:p>
+            <a:pPr algn="ctr"/>
+            <a:r>
+              <a:rPr sz="1000" b="0" i="0">
+                <a:solidFill>
+                  <a:srgbClr val="8A8AA3"/>
+                </a:solidFill>
+                <a:latin typeface="Inter"/>
+              </a:rPr>
+              <a:t>web pages + light JS</a:t>
+            </a:r>
+          </a:p>
+        </p:txBody>
+      </p:sp>
+      <p:sp>
+        <p:nvSpPr>
+          <p:cNvPr id="6" name="Rounded Rectangle 5"/>
+          <p:cNvSpPr/>
+          <p:nvPr/>
+        </p:nvSpPr>
+        <p:spPr>
+          <a:xfrm>
+            <a:off x="2880360" y="3063240"/>
+            <a:ext cx="6400800" cy="1828800"/>
+          </a:xfrm>
+          <a:prstGeom prst="roundRect">
+            <a:avLst/>
+          </a:prstGeom>
+          <a:solidFill>
+            <a:srgbClr val="10101A"/>
+          </a:solidFill>
+          <a:ln w="19050">
+            <a:solidFill>
+              <a:srgbClr val="9D8DF1"/>
+            </a:solidFill>
+          </a:ln>
+          <a:effectLst/>
+        </p:spPr>
+        <p:style>
+          <a:lnRef idx="1">
+            <a:schemeClr val="accent1"/>
+          </a:lnRef>
+          <a:fillRef idx="3">
+            <a:schemeClr val="accent1"/>
+          </a:fillRef>
+          <a:effectRef idx="2">
+            <a:schemeClr val="accent1"/>
+          </a:effectRef>
+          <a:fontRef idx="minor">
+            <a:schemeClr val="lt1"/>
+          </a:fontRef>
+        </p:style>
+        <p:txBody>
+          <a:bodyPr rtlCol="0" anchor="t" wrap="square" lIns="54864" rIns="54864" tIns="27432" bIns="27432"/>
+          <a:lstStyle/>
+          <a:p>
+            <a:pPr algn="ctr"/>
+            <a:r>
+              <a:rPr sz="1500" b="1" i="0">
+                <a:solidFill>
+                  <a:srgbClr val="EDEDF5"/>
+                </a:solidFill>
+                <a:latin typeface="Inter"/>
+              </a:rPr>
+              <a:t>FastAPI app  ·  Render</a:t>
+            </a:r>
+          </a:p>
+        </p:txBody>
+      </p:sp>
+      <p:sp>
+        <p:nvSpPr>
+          <p:cNvPr id="7" name="Rounded Rectangle 6"/>
+          <p:cNvSpPr/>
+          <p:nvPr/>
+        </p:nvSpPr>
+        <p:spPr>
+          <a:xfrm>
+            <a:off x="3063240" y="3611880"/>
+            <a:ext cx="1371600" cy="1051560"/>
+          </a:xfrm>
+          <a:prstGeom prst="roundRect">
+            <a:avLst/>
+          </a:prstGeom>
+          <a:solidFill>
+            <a:srgbClr val="15151F"/>
+          </a:solidFill>
+          <a:ln w="19050">
+            <a:solidFill>
+              <a:srgbClr val="2E2E44"/>
+            </a:solidFill>
+          </a:ln>
+          <a:effectLst/>
+        </p:spPr>
+        <p:style>
+          <a:lnRef idx="1">
+            <a:schemeClr val="accent1"/>
+          </a:lnRef>
+          <a:fillRef idx="3">
+            <a:schemeClr val="accent1"/>
+          </a:fillRef>
+          <a:effectRef idx="2">
+            <a:schemeClr val="accent1"/>
+          </a:effectRef>
+          <a:fontRef idx="minor">
+            <a:schemeClr val="lt1"/>
+          </a:fontRef>
+        </p:style>
+        <p:txBody>
+          <a:bodyPr rtlCol="0" anchor="ctr" wrap="square" lIns="54864" rIns="54864" tIns="27432" bIns="27432"/>
+          <a:lstStyle/>
+          <a:p>
+            <a:pPr algn="ctr"/>
+            <a:r>
+              <a:rPr sz="1200" b="1" i="0">
+                <a:solidFill>
+                  <a:srgbClr val="EDEDF5"/>
+                </a:solidFill>
+                <a:latin typeface="Inter"/>
+              </a:rPr>
+              <a:t>Web pages</a:t>
+            </a:r>
+          </a:p>
+          <a:p>
+            <a:pPr algn="ctr"/>
+            <a:r>
+              <a:rPr sz="900" b="0" i="0">
+                <a:solidFill>
+                  <a:srgbClr val="8A8AA3"/>
+                </a:solidFill>
+                <a:latin typeface="Inter"/>
+              </a:rPr>
+              <a:t>Jinja</a:t>
+            </a:r>
+          </a:p>
+        </p:txBody>
+      </p:sp>
+      <p:sp>
+        <p:nvSpPr>
+          <p:cNvPr id="8" name="Rounded Rectangle 7"/>
+          <p:cNvSpPr/>
+          <p:nvPr/>
+        </p:nvSpPr>
+        <p:spPr>
+          <a:xfrm>
+            <a:off x="4599432" y="3611880"/>
+            <a:ext cx="1371600" cy="1051560"/>
+          </a:xfrm>
+          <a:prstGeom prst="roundRect">
+            <a:avLst/>
+          </a:prstGeom>
+          <a:solidFill>
+            <a:srgbClr val="15151F"/>
+          </a:solidFill>
+          <a:ln w="19050">
+            <a:solidFill>
+              <a:srgbClr val="2E2E44"/>
+            </a:solidFill>
+          </a:ln>
+          <a:effectLst/>
+        </p:spPr>
+        <p:style>
+          <a:lnRef idx="1">
+            <a:schemeClr val="accent1"/>
+          </a:lnRef>
+          <a:fillRef idx="3">
+            <a:schemeClr val="accent1"/>
+          </a:fillRef>
+          <a:effectRef idx="2">
+            <a:schemeClr val="accent1"/>
+          </a:effectRef>
+          <a:fontRef idx="minor">
+            <a:schemeClr val="lt1"/>
+          </a:fontRef>
+        </p:style>
+        <p:txBody>
+          <a:bodyPr rtlCol="0" anchor="ctr" wrap="square" lIns="54864" rIns="54864" tIns="27432" bIns="27432"/>
+          <a:lstStyle/>
+          <a:p>
+            <a:pPr algn="ctr"/>
+            <a:r>
+              <a:rPr sz="1200" b="1" i="0">
+                <a:solidFill>
+                  <a:srgbClr val="EDEDF5"/>
+                </a:solidFill>
+                <a:latin typeface="Inter"/>
+              </a:rPr>
+              <a:t>JSON API</a:t>
+            </a:r>
+          </a:p>
+        </p:txBody>
+      </p:sp>
+      <p:sp>
+        <p:nvSpPr>
+          <p:cNvPr id="9" name="Rounded Rectangle 8"/>
+          <p:cNvSpPr/>
+          <p:nvPr/>
+        </p:nvSpPr>
+        <p:spPr>
+          <a:xfrm>
+            <a:off x="6135624" y="3611880"/>
+            <a:ext cx="1371600" cy="1051560"/>
+          </a:xfrm>
+          <a:prstGeom prst="roundRect">
+            <a:avLst/>
+          </a:prstGeom>
+          <a:solidFill>
+            <a:srgbClr val="15151F"/>
+          </a:solidFill>
+          <a:ln w="19050">
+            <a:solidFill>
+              <a:srgbClr val="2E2E44"/>
+            </a:solidFill>
+          </a:ln>
+          <a:effectLst/>
+        </p:spPr>
+        <p:style>
+          <a:lnRef idx="1">
+            <a:schemeClr val="accent1"/>
+          </a:lnRef>
+          <a:fillRef idx="3">
+            <a:schemeClr val="accent1"/>
+          </a:fillRef>
+          <a:effectRef idx="2">
+            <a:schemeClr val="accent1"/>
+          </a:effectRef>
+          <a:fontRef idx="minor">
+            <a:schemeClr val="lt1"/>
+          </a:fontRef>
+        </p:style>
+        <p:txBody>
+          <a:bodyPr rtlCol="0" anchor="ctr" wrap="square" lIns="54864" rIns="54864" tIns="27432" bIns="27432"/>
+          <a:lstStyle/>
+          <a:p>
+            <a:pPr algn="ctr"/>
+            <a:r>
+              <a:rPr sz="1200" b="1" i="0">
+                <a:solidFill>
+                  <a:srgbClr val="EDEDF5"/>
+                </a:solidFill>
+                <a:latin typeface="Inter"/>
+              </a:rPr>
+              <a:t>Auth</a:t>
+            </a:r>
+          </a:p>
+          <a:p>
+            <a:pPr algn="ctr"/>
+            <a:r>
+              <a:rPr sz="900" b="0" i="0">
+                <a:solidFill>
+                  <a:srgbClr val="8A8AA3"/>
+                </a:solidFill>
+                <a:latin typeface="Inter"/>
+              </a:rPr>
+              <a:t>JWT · AES-256</a:t>
+            </a:r>
+          </a:p>
+        </p:txBody>
+      </p:sp>
+      <p:sp>
+        <p:nvSpPr>
+          <p:cNvPr id="10" name="Rounded Rectangle 9"/>
+          <p:cNvSpPr/>
+          <p:nvPr/>
+        </p:nvSpPr>
+        <p:spPr>
+          <a:xfrm>
+            <a:off x="7671816" y="3611880"/>
+            <a:ext cx="1371600" cy="1051560"/>
+          </a:xfrm>
+          <a:prstGeom prst="roundRect">
+            <a:avLst/>
+          </a:prstGeom>
+          <a:solidFill>
+            <a:srgbClr val="15151F"/>
+          </a:solidFill>
+          <a:ln w="19050">
+            <a:solidFill>
+              <a:srgbClr val="2E2E44"/>
+            </a:solidFill>
+          </a:ln>
+          <a:effectLst/>
+        </p:spPr>
+        <p:style>
+          <a:lnRef idx="1">
+            <a:schemeClr val="accent1"/>
+          </a:lnRef>
+          <a:fillRef idx="3">
+            <a:schemeClr val="accent1"/>
+          </a:fillRef>
+          <a:effectRef idx="2">
+            <a:schemeClr val="accent1"/>
+          </a:effectRef>
+          <a:fontRef idx="minor">
+            <a:schemeClr val="lt1"/>
+          </a:fontRef>
+        </p:style>
+        <p:txBody>
+          <a:bodyPr rtlCol="0" anchor="ctr" wrap="square" lIns="54864" rIns="54864" tIns="27432" bIns="27432"/>
+          <a:lstStyle/>
+          <a:p>
+            <a:pPr algn="ctr"/>
+            <a:r>
+              <a:rPr sz="1200" b="1" i="0">
+                <a:solidFill>
+                  <a:srgbClr val="EDEDF5"/>
+                </a:solidFill>
+                <a:latin typeface="Inter"/>
+              </a:rPr>
+              <a:t>Inference</a:t>
+            </a:r>
+          </a:p>
+          <a:p>
+            <a:pPr algn="ctr"/>
+            <a:r>
+              <a:rPr sz="900" b="0" i="0">
+                <a:solidFill>
+                  <a:srgbClr val="8A8AA3"/>
+                </a:solidFill>
+                <a:latin typeface="Inter"/>
+              </a:rPr>
+              <a:t>on read</a:t>
+            </a:r>
+          </a:p>
+        </p:txBody>
+      </p:sp>
+      <p:sp>
+        <p:nvSpPr>
+          <p:cNvPr id="11" name="Rounded Rectangle 10"/>
+          <p:cNvSpPr/>
+          <p:nvPr/>
+        </p:nvSpPr>
+        <p:spPr>
+          <a:xfrm>
+            <a:off x="2011680" y="5257800"/>
+            <a:ext cx="4206240" cy="1280160"/>
+          </a:xfrm>
+          <a:prstGeom prst="roundRect">
+            <a:avLst/>
+          </a:prstGeom>
+          <a:solidFill>
+            <a:srgbClr val="10101A"/>
+          </a:solidFill>
+          <a:ln w="19050">
+            <a:solidFill>
+              <a:srgbClr val="5EEAD4"/>
+            </a:solidFill>
+          </a:ln>
+          <a:effectLst/>
+        </p:spPr>
+        <p:style>
+          <a:lnRef idx="1">
+            <a:schemeClr val="accent1"/>
+          </a:lnRef>
+          <a:fillRef idx="3">
+            <a:schemeClr val="accent1"/>
+          </a:fillRef>
+          <a:effectRef idx="2">
+            <a:schemeClr val="accent1"/>
+          </a:effectRef>
+          <a:fontRef idx="minor">
+            <a:schemeClr val="lt1"/>
+          </a:fontRef>
+        </p:style>
+        <p:txBody>
+          <a:bodyPr rtlCol="0" anchor="t" wrap="square" lIns="54864" rIns="54864" tIns="27432" bIns="27432"/>
+          <a:lstStyle/>
+          <a:p>
+            <a:pPr algn="ctr"/>
+            <a:r>
+              <a:rPr sz="1400" b="1" i="0">
+                <a:solidFill>
+                  <a:srgbClr val="EDEDF5"/>
+                </a:solidFill>
+                <a:latin typeface="Inter"/>
+              </a:rPr>
+              <a:t>Supabase</a:t>
+            </a:r>
+          </a:p>
+        </p:txBody>
+      </p:sp>
+      <p:sp>
+        <p:nvSpPr>
+          <p:cNvPr id="12" name="Rounded Rectangle 11"/>
+          <p:cNvSpPr/>
+          <p:nvPr/>
+        </p:nvSpPr>
+        <p:spPr>
+          <a:xfrm>
+            <a:off x="2148840" y="5715000"/>
+            <a:ext cx="1828800" cy="731520"/>
+          </a:xfrm>
+          <a:prstGeom prst="roundRect">
+            <a:avLst/>
+          </a:prstGeom>
+          <a:solidFill>
+            <a:srgbClr val="15151F"/>
+          </a:solidFill>
+          <a:ln w="19050">
+            <a:solidFill>
+              <a:srgbClr val="2E2E44"/>
+            </a:solidFill>
+          </a:ln>
+          <a:effectLst/>
+        </p:spPr>
+        <p:style>
+          <a:lnRef idx="1">
+            <a:schemeClr val="accent1"/>
+          </a:lnRef>
+          <a:fillRef idx="3">
+            <a:schemeClr val="accent1"/>
+          </a:fillRef>
+          <a:effectRef idx="2">
+            <a:schemeClr val="accent1"/>
+          </a:effectRef>
+          <a:fontRef idx="minor">
+            <a:schemeClr val="lt1"/>
+          </a:fontRef>
+        </p:style>
+        <p:txBody>
+          <a:bodyPr rtlCol="0" anchor="ctr" wrap="square" lIns="54864" rIns="54864" tIns="27432" bIns="27432"/>
+          <a:lstStyle/>
+          <a:p>
+            <a:pPr algn="ctr"/>
+            <a:r>
+              <a:rPr sz="1100" b="1" i="0">
+                <a:solidFill>
+                  <a:srgbClr val="EDEDF5"/>
+                </a:solidFill>
+                <a:latin typeface="Inter"/>
+              </a:rPr>
+              <a:t>Postgres</a:t>
+            </a:r>
+          </a:p>
+          <a:p>
+            <a:pPr algn="ctr"/>
+            <a:r>
+              <a:rPr sz="800" b="0" i="0">
+                <a:solidFill>
+                  <a:srgbClr val="8A8AA3"/>
+                </a:solidFill>
+                <a:latin typeface="Inter"/>
+              </a:rPr>
+              <a:t>public + bronze/silver/gold</a:t>
+            </a:r>
+          </a:p>
+        </p:txBody>
+      </p:sp>
+      <p:sp>
+        <p:nvSpPr>
+          <p:cNvPr id="13" name="Rounded Rectangle 12"/>
+          <p:cNvSpPr/>
+          <p:nvPr/>
+        </p:nvSpPr>
+        <p:spPr>
+          <a:xfrm>
+            <a:off x="4069080" y="5715000"/>
+            <a:ext cx="822960" cy="731520"/>
+          </a:xfrm>
+          <a:prstGeom prst="roundRect">
+            <a:avLst/>
+          </a:prstGeom>
+          <a:solidFill>
+            <a:srgbClr val="15151F"/>
+          </a:solidFill>
+          <a:ln w="19050">
+            <a:solidFill>
+              <a:srgbClr val="2E2E44"/>
+            </a:solidFill>
+          </a:ln>
+          <a:effectLst/>
+        </p:spPr>
+        <p:style>
+          <a:lnRef idx="1">
+            <a:schemeClr val="accent1"/>
+          </a:lnRef>
+          <a:fillRef idx="3">
+            <a:schemeClr val="accent1"/>
+          </a:fillRef>
+          <a:effectRef idx="2">
+            <a:schemeClr val="accent1"/>
+          </a:effectRef>
+          <a:fontRef idx="minor">
+            <a:schemeClr val="lt1"/>
+          </a:fontRef>
+        </p:style>
+        <p:txBody>
+          <a:bodyPr rtlCol="0" anchor="ctr" wrap="square" lIns="54864" rIns="54864" tIns="27432" bIns="27432"/>
+          <a:lstStyle/>
+          <a:p>
+            <a:pPr algn="ctr"/>
+            <a:r>
+              <a:rPr sz="1100" b="1" i="0">
+                <a:solidFill>
+                  <a:srgbClr val="EDEDF5"/>
+                </a:solidFill>
+                <a:latin typeface="Inter"/>
+              </a:rPr>
+              <a:t>Auth</a:t>
+            </a:r>
+          </a:p>
+        </p:txBody>
+      </p:sp>
+      <p:sp>
+        <p:nvSpPr>
+          <p:cNvPr id="14" name="Rounded Rectangle 13"/>
+          <p:cNvSpPr/>
+          <p:nvPr/>
+        </p:nvSpPr>
+        <p:spPr>
+          <a:xfrm>
+            <a:off x="4983480" y="5715000"/>
+            <a:ext cx="822960" cy="731520"/>
+          </a:xfrm>
+          <a:prstGeom prst="roundRect">
+            <a:avLst/>
+          </a:prstGeom>
+          <a:solidFill>
+            <a:srgbClr val="15151F"/>
+          </a:solidFill>
+          <a:ln w="19050">
+            <a:solidFill>
+              <a:srgbClr val="2E2E44"/>
+            </a:solidFill>
+          </a:ln>
+          <a:effectLst/>
+        </p:spPr>
+        <p:style>
+          <a:lnRef idx="1">
+            <a:schemeClr val="accent1"/>
+          </a:lnRef>
+          <a:fillRef idx="3">
+            <a:schemeClr val="accent1"/>
+          </a:fillRef>
+          <a:effectRef idx="2">
+            <a:schemeClr val="accent1"/>
+          </a:effectRef>
+          <a:fontRef idx="minor">
+            <a:schemeClr val="lt1"/>
+          </a:fontRef>
+        </p:style>
+        <p:txBody>
+          <a:bodyPr rtlCol="0" anchor="ctr" wrap="square" lIns="54864" rIns="54864" tIns="27432" bIns="27432"/>
+          <a:lstStyle/>
+          <a:p>
+            <a:pPr algn="ctr"/>
+            <a:r>
+              <a:rPr sz="1100" b="1" i="0">
+                <a:solidFill>
+                  <a:srgbClr val="EDEDF5"/>
+                </a:solidFill>
+                <a:latin typeface="Inter"/>
+              </a:rPr>
+              <a:t>Storage</a:t>
+            </a:r>
+          </a:p>
+        </p:txBody>
+      </p:sp>
+      <p:sp>
+        <p:nvSpPr>
+          <p:cNvPr id="15" name="Rounded Rectangle 14"/>
+          <p:cNvSpPr/>
+          <p:nvPr/>
+        </p:nvSpPr>
+        <p:spPr>
+          <a:xfrm>
+            <a:off x="6720840" y="5257800"/>
+            <a:ext cx="3017520" cy="1280160"/>
+          </a:xfrm>
+          <a:prstGeom prst="roundRect">
+            <a:avLst/>
+          </a:prstGeom>
+          <a:solidFill>
+            <a:srgbClr val="15151F"/>
+          </a:solidFill>
+          <a:ln w="19050">
+            <a:solidFill>
+              <a:srgbClr val="F472B6"/>
+            </a:solidFill>
+          </a:ln>
+          <a:effectLst/>
+        </p:spPr>
+        <p:style>
+          <a:lnRef idx="1">
+            <a:schemeClr val="accent1"/>
+          </a:lnRef>
+          <a:fillRef idx="3">
+            <a:schemeClr val="accent1"/>
+          </a:fillRef>
+          <a:effectRef idx="2">
+            <a:schemeClr val="accent1"/>
+          </a:effectRef>
+          <a:fontRef idx="minor">
+            <a:schemeClr val="lt1"/>
+          </a:fontRef>
+        </p:style>
+        <p:txBody>
+          <a:bodyPr rtlCol="0" anchor="ctr" wrap="square" lIns="54864" rIns="54864" tIns="27432" bIns="27432"/>
+          <a:lstStyle/>
+          <a:p>
+            <a:pPr algn="ctr"/>
+            <a:r>
+              <a:rPr sz="1300" b="1" i="0">
+                <a:solidFill>
+                  <a:srgbClr val="EDEDF5"/>
+                </a:solidFill>
+                <a:latin typeface="Inter"/>
+              </a:rPr>
+              <a:t>Analytics pipeline</a:t>
+            </a:r>
+          </a:p>
+          <a:p>
+            <a:pPr algn="ctr"/>
+            <a:r>
+              <a:rPr sz="1000" b="0" i="0">
+                <a:solidFill>
+                  <a:srgbClr val="8A8AA3"/>
+                </a:solidFill>
+                <a:latin typeface="Inter"/>
+              </a:rPr>
+              <a:t>GitHub Actions · nightly
+trains K-means → writes gold</a:t>
+            </a:r>
+          </a:p>
+        </p:txBody>
+      </p:sp>
+      <p:cxnSp>
+        <p:nvCxnSpPr>
+          <p:cNvPr id="16" name="Connector 15"/>
+          <p:cNvCxnSpPr/>
+          <p:nvPr/>
+        </p:nvCxnSpPr>
+        <p:spPr>
+          <a:xfrm>
+            <a:off x="6080760" y="2651760"/>
+            <a:ext cx="0" cy="411480"/>
+          </a:xfrm>
+          <a:prstGeom prst="line">
+            <a:avLst/>
+          </a:prstGeom>
+          <a:ln w="22225">
+            <a:solidFill>
+              <a:srgbClr val="9D8DF1"/>
+            </a:solidFill>
+            <a:tailEnd type="triangle"/>
+          </a:ln>
+          <a:effectLst/>
+        </p:spPr>
+        <p:style>
+          <a:lnRef idx="2">
+            <a:schemeClr val="accent1"/>
+          </a:lnRef>
+          <a:fillRef idx="0">
+            <a:schemeClr val="accent1"/>
+          </a:fillRef>
+          <a:effectRef idx="1">
+            <a:schemeClr val="accent1"/>
+          </a:effectRef>
+          <a:fontRef idx="minor">
+            <a:schemeClr val="tx1"/>
+          </a:fontRef>
+        </p:style>
+      </p:cxnSp>
+      <p:sp>
+        <p:nvSpPr>
+          <p:cNvPr id="17" name="TextBox 16"/>
           <p:cNvSpPr txBox="1"/>
           <p:nvPr/>
         </p:nvSpPr>
         <p:spPr>
           <a:xfrm>
-            <a:off x="640080" y="2331720"/>
-            <a:ext cx="10881360" cy="4023360"/>
+            <a:off x="6172200" y="2697480"/>
+            <a:ext cx="2194560" cy="274320"/>
           </a:xfrm>
           <a:prstGeom prst="rect">
             <a:avLst/>
@@ -8809,83 +9991,267 @@
           </a:bodyPr>
           <a:lstStyle/>
           <a:p>
-            <a:pPr>
-              <a:spcAft>
-                <a:spcPts val="1200"/>
-              </a:spcAft>
-            </a:pPr>
-            <a:r>
-              <a:rPr sz="2000" b="0" i="0">
-                <a:solidFill>
-                  <a:srgbClr val="EDEDF5"/>
-                </a:solidFill>
-                <a:latin typeface="Inter"/>
-              </a:rPr>
-              <a:t>•  One FastAPI app on Render serves the JSON API AND the HTML pages — same-origin, no CORS</a:t>
-            </a:r>
-          </a:p>
-          <a:p>
-            <a:pPr>
-              <a:spcAft>
-                <a:spcPts val="1200"/>
-              </a:spcAft>
-            </a:pPr>
-            <a:r>
-              <a:rPr sz="2000" b="0" i="0">
-                <a:solidFill>
-                  <a:srgbClr val="EDEDF5"/>
-                </a:solidFill>
-                <a:latin typeface="Inter"/>
-              </a:rPr>
-              <a:t>•  Supabase provides Postgres, Auth, and Storage</a:t>
-            </a:r>
-          </a:p>
-          <a:p>
-            <a:pPr>
-              <a:spcAft>
-                <a:spcPts val="1200"/>
-              </a:spcAft>
-            </a:pPr>
-            <a:r>
-              <a:rPr sz="2000" b="0" i="0">
-                <a:solidFill>
-                  <a:srgbClr val="EDEDF5"/>
-                </a:solidFill>
-                <a:latin typeface="Inter"/>
-              </a:rPr>
-              <a:t>•  We own long-term Spotify access via an encrypted stored refresh token</a:t>
-            </a:r>
-          </a:p>
-          <a:p>
-            <a:pPr>
-              <a:spcAft>
-                <a:spcPts val="1200"/>
-              </a:spcAft>
-            </a:pPr>
-            <a:r>
-              <a:rPr sz="2000" b="0" i="0">
-                <a:solidFill>
-                  <a:srgbClr val="EDEDF5"/>
-                </a:solidFill>
-                <a:latin typeface="Inter"/>
-              </a:rPr>
-              <a:t>•  A nightly Python analytics job trains the model and writes results the app reads live</a:t>
-            </a:r>
-          </a:p>
-          <a:p>
-            <a:pPr>
-              <a:spcAft>
-                <a:spcPts val="1200"/>
-              </a:spcAft>
-            </a:pPr>
-            <a:r>
-              <a:rPr sz="2000" b="0" i="0">
-                <a:solidFill>
-                  <a:srgbClr val="EDEDF5"/>
-                </a:solidFill>
-                <a:latin typeface="Inter"/>
-              </a:rPr>
-              <a:t>•  Simple, cheap, entirely on free tiers.</a:t>
+            <a:pPr algn="ctr"/>
+            <a:r>
+              <a:rPr sz="1000" b="0" i="0">
+                <a:solidFill>
+                  <a:srgbClr val="9D8DF1"/>
+                </a:solidFill>
+                <a:latin typeface="Inter"/>
+              </a:rPr>
+              <a:t>HTTPS · same-origin</a:t>
+            </a:r>
+          </a:p>
+        </p:txBody>
+      </p:sp>
+      <p:cxnSp>
+        <p:nvCxnSpPr>
+          <p:cNvPr id="18" name="Connector 17"/>
+          <p:cNvCxnSpPr/>
+          <p:nvPr/>
+        </p:nvCxnSpPr>
+        <p:spPr>
+          <a:xfrm>
+            <a:off x="2377440" y="2651760"/>
+            <a:ext cx="1280160" cy="411480"/>
+          </a:xfrm>
+          <a:prstGeom prst="line">
+            <a:avLst/>
+          </a:prstGeom>
+          <a:ln w="22225">
+            <a:solidFill>
+              <a:srgbClr val="F472B6"/>
+            </a:solidFill>
+            <a:tailEnd type="triangle"/>
+            <a:headEnd type="triangle"/>
+          </a:ln>
+          <a:effectLst/>
+        </p:spPr>
+        <p:style>
+          <a:lnRef idx="2">
+            <a:schemeClr val="accent1"/>
+          </a:lnRef>
+          <a:fillRef idx="0">
+            <a:schemeClr val="accent1"/>
+          </a:fillRef>
+          <a:effectRef idx="1">
+            <a:schemeClr val="accent1"/>
+          </a:effectRef>
+          <a:fontRef idx="minor">
+            <a:schemeClr val="tx1"/>
+          </a:fontRef>
+        </p:style>
+      </p:cxnSp>
+      <p:sp>
+        <p:nvSpPr>
+          <p:cNvPr id="19" name="TextBox 18"/>
+          <p:cNvSpPr txBox="1"/>
+          <p:nvPr/>
+        </p:nvSpPr>
+        <p:spPr>
+          <a:xfrm>
+            <a:off x="640080" y="2743200"/>
+            <a:ext cx="2103120" cy="274320"/>
+          </a:xfrm>
+          <a:prstGeom prst="rect">
+            <a:avLst/>
+          </a:prstGeom>
+          <a:noFill/>
+        </p:spPr>
+        <p:txBody>
+          <a:bodyPr wrap="square">
+            <a:spAutoFit/>
+          </a:bodyPr>
+          <a:lstStyle/>
+          <a:p>
+            <a:pPr algn="ctr"/>
+            <a:r>
+              <a:rPr sz="1000" b="0" i="0">
+                <a:solidFill>
+                  <a:srgbClr val="F472B6"/>
+                </a:solidFill>
+                <a:latin typeface="Inter"/>
+              </a:rPr>
+              <a:t>OAuth · now playing</a:t>
+            </a:r>
+          </a:p>
+        </p:txBody>
+      </p:sp>
+      <p:cxnSp>
+        <p:nvCxnSpPr>
+          <p:cNvPr id="20" name="Connector 19"/>
+          <p:cNvCxnSpPr/>
+          <p:nvPr/>
+        </p:nvCxnSpPr>
+        <p:spPr>
+          <a:xfrm flipH="1">
+            <a:off x="4206240" y="4892040"/>
+            <a:ext cx="365760" cy="365760"/>
+          </a:xfrm>
+          <a:prstGeom prst="line">
+            <a:avLst/>
+          </a:prstGeom>
+          <a:ln w="22225">
+            <a:solidFill>
+              <a:srgbClr val="5EEAD4"/>
+            </a:solidFill>
+            <a:tailEnd type="triangle"/>
+          </a:ln>
+          <a:effectLst/>
+        </p:spPr>
+        <p:style>
+          <a:lnRef idx="2">
+            <a:schemeClr val="accent1"/>
+          </a:lnRef>
+          <a:fillRef idx="0">
+            <a:schemeClr val="accent1"/>
+          </a:fillRef>
+          <a:effectRef idx="1">
+            <a:schemeClr val="accent1"/>
+          </a:effectRef>
+          <a:fontRef idx="minor">
+            <a:schemeClr val="tx1"/>
+          </a:fontRef>
+        </p:style>
+      </p:cxnSp>
+      <p:sp>
+        <p:nvSpPr>
+          <p:cNvPr id="21" name="TextBox 20"/>
+          <p:cNvSpPr txBox="1"/>
+          <p:nvPr/>
+        </p:nvSpPr>
+        <p:spPr>
+          <a:xfrm>
+            <a:off x="4480560" y="4956048"/>
+            <a:ext cx="2011680" cy="274320"/>
+          </a:xfrm>
+          <a:prstGeom prst="rect">
+            <a:avLst/>
+          </a:prstGeom>
+          <a:noFill/>
+        </p:spPr>
+        <p:txBody>
+          <a:bodyPr wrap="square">
+            <a:spAutoFit/>
+          </a:bodyPr>
+          <a:lstStyle/>
+          <a:p>
+            <a:pPr algn="ctr"/>
+            <a:r>
+              <a:rPr sz="1000" b="0" i="0">
+                <a:solidFill>
+                  <a:srgbClr val="5EEAD4"/>
+                </a:solidFill>
+                <a:latin typeface="Inter"/>
+              </a:rPr>
+              <a:t>SQLModel ORM</a:t>
+            </a:r>
+          </a:p>
+        </p:txBody>
+      </p:sp>
+      <p:cxnSp>
+        <p:nvCxnSpPr>
+          <p:cNvPr id="22" name="Connector 21"/>
+          <p:cNvCxnSpPr/>
+          <p:nvPr/>
+        </p:nvCxnSpPr>
+        <p:spPr>
+          <a:xfrm flipH="1">
+            <a:off x="6263640" y="5897880"/>
+            <a:ext cx="457200" cy="91440"/>
+          </a:xfrm>
+          <a:prstGeom prst="line">
+            <a:avLst/>
+          </a:prstGeom>
+          <a:ln w="22225">
+            <a:solidFill>
+              <a:srgbClr val="F472B6"/>
+            </a:solidFill>
+            <a:tailEnd type="triangle"/>
+          </a:ln>
+          <a:effectLst/>
+        </p:spPr>
+        <p:style>
+          <a:lnRef idx="2">
+            <a:schemeClr val="accent1"/>
+          </a:lnRef>
+          <a:fillRef idx="0">
+            <a:schemeClr val="accent1"/>
+          </a:fillRef>
+          <a:effectRef idx="1">
+            <a:schemeClr val="accent1"/>
+          </a:effectRef>
+          <a:fontRef idx="minor">
+            <a:schemeClr val="tx1"/>
+          </a:fontRef>
+        </p:style>
+      </p:cxnSp>
+      <p:sp>
+        <p:nvSpPr>
+          <p:cNvPr id="23" name="TextBox 22"/>
+          <p:cNvSpPr txBox="1"/>
+          <p:nvPr/>
+        </p:nvSpPr>
+        <p:spPr>
+          <a:xfrm>
+            <a:off x="6126480" y="6263640"/>
+            <a:ext cx="2011680" cy="274320"/>
+          </a:xfrm>
+          <a:prstGeom prst="rect">
+            <a:avLst/>
+          </a:prstGeom>
+          <a:noFill/>
+        </p:spPr>
+        <p:txBody>
+          <a:bodyPr wrap="square">
+            <a:spAutoFit/>
+          </a:bodyPr>
+          <a:lstStyle/>
+          <a:p>
+            <a:pPr algn="ctr"/>
+            <a:r>
+              <a:rPr sz="1000" b="0" i="0">
+                <a:solidFill>
+                  <a:srgbClr val="F472B6"/>
+                </a:solidFill>
+                <a:latin typeface="Inter"/>
+              </a:rPr>
+              <a:t>writes gold</a:t>
+            </a:r>
+          </a:p>
+        </p:txBody>
+      </p:sp>
+      <p:sp>
+        <p:nvSpPr>
+          <p:cNvPr id="24" name="TextBox 23"/>
+          <p:cNvSpPr txBox="1"/>
+          <p:nvPr/>
+        </p:nvSpPr>
+        <p:spPr>
+          <a:xfrm>
+            <a:off x="640080" y="6446520"/>
+            <a:ext cx="10881360" cy="365760"/>
+          </a:xfrm>
+          <a:prstGeom prst="rect">
+            <a:avLst/>
+          </a:prstGeom>
+          <a:noFill/>
+        </p:spPr>
+        <p:txBody>
+          <a:bodyPr wrap="square">
+            <a:spAutoFit/>
+          </a:bodyPr>
+          <a:lstStyle/>
+          <a:p>
+            <a:pPr algn="ctr"/>
+            <a:r>
+              <a:rPr sz="1300" b="0" i="1">
+                <a:solidFill>
+                  <a:srgbClr val="8A8AA3"/>
+                </a:solidFill>
+                <a:latin typeface="Inter"/>
+              </a:rPr>
+              <a:t>One app is everything the user touches. A nightly job trains the model on the side; the app just reads the results.</a:t>
             </a:r>
           </a:p>
         </p:txBody>
@@ -8945,7 +10311,7 @@
                 </a:solidFill>
                 <a:latin typeface="Inter"/>
               </a:rPr>
-              <a:t>ANDREA · 1:00</a:t>
+              <a:t>ANDREA · 0:50</a:t>
             </a:r>
           </a:p>
         </p:txBody>
@@ -8959,7 +10325,7 @@
         <p:spPr>
           <a:xfrm>
             <a:off x="640080" y="868680"/>
-            <a:ext cx="10881360" cy="1188720"/>
+            <a:ext cx="10881360" cy="1280160"/>
           </a:xfrm>
           <a:prstGeom prst="rect">
             <a:avLst/>
@@ -8973,13 +10339,13 @@
           <a:lstStyle/>
           <a:p>
             <a:r>
-              <a:rPr sz="3400" b="1" i="0">
+              <a:rPr sz="3200" b="1" i="0">
                 <a:solidFill>
                   <a:srgbClr val="9D8DF1"/>
                 </a:solidFill>
                 <a:latin typeface="Inter"/>
               </a:rPr>
-              <a:t>The data model  (~14 tables)</a:t>
+              <a:t>The data behind it  (~14 tables)</a:t>
             </a:r>
           </a:p>
         </p:txBody>
@@ -8992,8 +10358,8 @@
         </p:nvSpPr>
         <p:spPr>
           <a:xfrm>
-            <a:off x="658368" y="1965960"/>
-            <a:ext cx="1463040" cy="38100"/>
+            <a:off x="658368" y="2011680"/>
+            <a:ext cx="1371600" cy="38100"/>
           </a:xfrm>
           <a:prstGeom prst="rect">
             <a:avLst/>
@@ -9036,7 +10402,7 @@
         </p:nvSpPr>
         <p:spPr>
           <a:xfrm>
-            <a:off x="640080" y="2331720"/>
+            <a:off x="640080" y="2377440"/>
             <a:ext cx="10881360" cy="4023360"/>
           </a:xfrm>
           <a:prstGeom prst="rect">
@@ -9052,7 +10418,7 @@
           <a:p>
             <a:pPr>
               <a:spcAft>
-                <a:spcPts val="1200"/>
+                <a:spcPts val="1400"/>
               </a:spcAft>
             </a:pPr>
             <a:r>
@@ -9062,13 +10428,13 @@
                 </a:solidFill>
                 <a:latin typeface="Inter"/>
               </a:rPr>
-              <a:t>Social (public):  User · Post · Reaction · Comment · Follow · ArtistPost</a:t>
+              <a:t>Social:  users, posts, reactions, comments, the follow graph</a:t>
             </a:r>
           </a:p>
           <a:p>
             <a:pPr>
               <a:spcAft>
-                <a:spcPts val="1200"/>
+                <a:spcPts val="1400"/>
               </a:spcAft>
             </a:pPr>
             <a:r>
@@ -9078,13 +10444,13 @@
                 </a:solidFill>
                 <a:latin typeface="Inter"/>
               </a:rPr>
-              <a:t>Analytics (medallion):  silver.Track · silver.Play · gold.Cluster · gold.ModelArtifact · bronze.*_raw</a:t>
+              <a:t>Music &amp; model:  tracks, plays, and the taste communities the model produces</a:t>
             </a:r>
           </a:p>
           <a:p>
             <a:pPr>
               <a:spcAft>
-                <a:spcPts val="1200"/>
+                <a:spcPts val="1400"/>
               </a:spcAft>
             </a:pPr>
             <a:r>
@@ -9094,7 +10460,23 @@
                 </a:solidFill>
                 <a:latin typeface="Inter"/>
               </a:rPr>
-              <a:t>•  A user's cluster &amp; compatibility aren't stored — they're computed on read, so never stale.</a:t>
+              <a:t>•  A person's community and compatibility aren't stored — we work them out on the spot,</a:t>
+            </a:r>
+          </a:p>
+          <a:p>
+            <a:pPr>
+              <a:spcAft>
+                <a:spcPts val="1400"/>
+              </a:spcAft>
+            </a:pPr>
+            <a:r>
+              <a:rPr sz="2000" b="0" i="0">
+                <a:solidFill>
+                  <a:srgbClr val="EDEDF5"/>
+                </a:solidFill>
+                <a:latin typeface="Inter"/>
+              </a:rPr>
+              <a:t>•  so they're never stale and always reflect the latest listening.</a:t>
             </a:r>
           </a:p>
         </p:txBody>
@@ -9168,7 +10550,7 @@
         <p:spPr>
           <a:xfrm>
             <a:off x="640080" y="868680"/>
-            <a:ext cx="10881360" cy="1188720"/>
+            <a:ext cx="10881360" cy="1280160"/>
           </a:xfrm>
           <a:prstGeom prst="rect">
             <a:avLst/>
@@ -9182,13 +10564,13 @@
           <a:lstStyle/>
           <a:p>
             <a:r>
-              <a:rPr sz="3400" b="1" i="0">
+              <a:rPr sz="3200" b="1" i="0">
                 <a:solidFill>
                   <a:srgbClr val="9D8DF1"/>
                 </a:solidFill>
                 <a:latin typeface="Inter"/>
               </a:rPr>
-              <a:t>Auth &amp; security</a:t>
+              <a:t>Keeping accounts safe</a:t>
             </a:r>
           </a:p>
         </p:txBody>
@@ -9201,8 +10583,8 @@
         </p:nvSpPr>
         <p:spPr>
           <a:xfrm>
-            <a:off x="658368" y="1965960"/>
-            <a:ext cx="1463040" cy="38100"/>
+            <a:off x="658368" y="2011680"/>
+            <a:ext cx="1371600" cy="38100"/>
           </a:xfrm>
           <a:prstGeom prst="rect">
             <a:avLst/>
@@ -9245,7 +10627,7 @@
         </p:nvSpPr>
         <p:spPr>
           <a:xfrm>
-            <a:off x="640080" y="2331720"/>
+            <a:off x="640080" y="2377440"/>
             <a:ext cx="10881360" cy="4023360"/>
           </a:xfrm>
           <a:prstGeom prst="rect">
@@ -9261,23 +10643,23 @@
           <a:p>
             <a:pPr>
               <a:spcAft>
-                <a:spcPts val="1200"/>
+                <a:spcPts val="1400"/>
               </a:spcAft>
             </a:pPr>
             <a:r>
-              <a:rPr sz="2000" b="1" i="0">
-                <a:solidFill>
-                  <a:srgbClr val="F472B6"/>
-                </a:solidFill>
-                <a:latin typeface="Inter"/>
-              </a:rPr>
-              <a:t>Server-side JWT validation — we never hold a JWT secret</a:t>
+              <a:rPr sz="2000" b="0" i="0">
+                <a:solidFill>
+                  <a:srgbClr val="EDEDF5"/>
+                </a:solidFill>
+                <a:latin typeface="Inter"/>
+              </a:rPr>
+              <a:t>•  We check every login on our server — we never hold a master key.</a:t>
             </a:r>
           </a:p>
           <a:p>
             <a:pPr>
               <a:spcAft>
-                <a:spcPts val="1200"/>
+                <a:spcPts val="1400"/>
               </a:spcAft>
             </a:pPr>
             <a:r>
@@ -9287,29 +10669,29 @@
                 </a:solidFill>
                 <a:latin typeface="Inter"/>
               </a:rPr>
-              <a:t>Spotify tokens encrypted at rest — AES-256-GCM</a:t>
+              <a:t>Spotify tokens are encrypted before they're stored  (AES-256-GCM).</a:t>
             </a:r>
           </a:p>
           <a:p>
             <a:pPr>
               <a:spcAft>
-                <a:spcPts val="1200"/>
+                <a:spcPts val="1400"/>
               </a:spcAft>
             </a:pPr>
             <a:r>
-              <a:rPr sz="2000" b="1" i="0">
-                <a:solidFill>
-                  <a:srgbClr val="F472B6"/>
-                </a:solidFill>
-                <a:latin typeface="Inter"/>
-              </a:rPr>
-              <a:t>Per-user rate limiting + secret-scanning in CI and pre-commit</a:t>
+              <a:rPr sz="2000" b="0" i="0">
+                <a:solidFill>
+                  <a:srgbClr val="EDEDF5"/>
+                </a:solidFill>
+                <a:latin typeface="Inter"/>
+              </a:rPr>
+              <a:t>•  Limits on how fast anyone can post, and a secret-scanner on every commit.</a:t>
             </a:r>
           </a:p>
           <a:p>
             <a:pPr>
               <a:spcAft>
-                <a:spcPts val="1200"/>
+                <a:spcPts val="1400"/>
               </a:spcAft>
             </a:pPr>
             <a:r>
@@ -9319,7 +10701,7 @@
                 </a:solidFill>
                 <a:latin typeface="Inter"/>
               </a:rPr>
-              <a:t>•  Security was the reason for the Python pivot — so we take it seriously.</a:t>
+              <a:t>•  Security was the reason we moved to Python — so we took it seriously.</a:t>
             </a:r>
           </a:p>
         </p:txBody>

</xml_diff>